<commit_message>
Fill half-empty areas of the design thinking deck
Co-Authored-By: Claude Sonnet 5.5 <noreply@anthropic.com>
Claude-Session: https://claude.ai/code/session_01G91AnPjqU4wM8Huv9evsac
</commit_message>
<xml_diff>
--- a/docs/Ramer_Design_Thinking.pptx
+++ b/docs/Ramer_Design_Thinking.pptx
@@ -3481,6 +3481,45 @@
           </a:p>
         </p:txBody>
       </p:sp>
+      <p:sp>
+        <p:nvSpPr>
+          <p:cNvPr id="6" name="Text 3"/>
+          <p:cNvSpPr txBox="1"/>
+          <p:nvPr/>
+        </p:nvSpPr>
+        <p:spPr>
+          <a:xfrm>
+            <a:off x="548640" y="4114800"/>
+            <a:ext cx="8046720" cy="320040"/>
+          </a:xfrm>
+          <a:prstGeom prst="rect">
+            <a:avLst/>
+          </a:prstGeom>
+          <a:noFill/>
+          <a:ln/>
+        </p:spPr>
+        <p:txBody>
+          <a:bodyPr wrap="square" lIns="0" tIns="0" rIns="0" bIns="0" rtlCol="0" anchor="ctr"/>
+          <a:lstStyle/>
+          <a:p>
+            <a:pPr indent="0" marL="0">
+              <a:buNone/>
+            </a:pPr>
+            <a:r>
+              <a:rPr lang="en-US" sz="1300" b="1" spc="200" kern="0" dirty="0">
+                <a:solidFill>
+                  <a:srgbClr val="8C8C8C"/>
+                </a:solidFill>
+                <a:latin typeface="Arial" pitchFamily="34" charset="0"/>
+                <a:ea typeface="Arial" pitchFamily="34" charset="-122"/>
+                <a:cs typeface="Arial" pitchFamily="34" charset="-120"/>
+              </a:rPr>
+              <a:t>EMPATHIZE   ·   DEFINE   ·   IDEATE   ·   PROTOTYPE   ·   TEST</a:t>
+            </a:r>
+            <a:endParaRPr lang="en-US" sz="1300" dirty="0"/>
+          </a:p>
+        </p:txBody>
+      </p:sp>
     </p:spTree>
   </p:cSld>
   <p:clrMapOvr>
@@ -3599,8 +3638,8 @@
         </p:nvSpPr>
         <p:spPr>
           <a:xfrm>
-            <a:off x="548640" y="2697480"/>
-            <a:ext cx="3474720" cy="914400"/>
+            <a:off x="548640" y="2560320"/>
+            <a:ext cx="3474720" cy="640080"/>
           </a:xfrm>
           <a:prstGeom prst="rect">
             <a:avLst/>
@@ -3616,7 +3655,7 @@
               <a:buNone/>
             </a:pPr>
             <a:r>
-              <a:rPr lang="en-US" sz="1800" i="1" dirty="0">
+              <a:rPr lang="en-US" sz="1600" i="1" dirty="0">
                 <a:solidFill>
                   <a:srgbClr val="BFBFBF"/>
                 </a:solidFill>
@@ -3626,13 +3665,403 @@
               </a:rPr>
               <a:t>Go wide first, then choose.</a:t>
             </a:r>
-            <a:endParaRPr lang="en-US" sz="1800" dirty="0"/>
-          </a:p>
-        </p:txBody>
-      </p:sp>
-      <p:sp>
-        <p:nvSpPr>
-          <p:cNvPr id="6" name="Shape 3"/>
+            <a:endParaRPr lang="en-US" sz="1600" dirty="0"/>
+          </a:p>
+        </p:txBody>
+      </p:sp>
+      <p:sp>
+        <p:nvSpPr>
+          <p:cNvPr id="6" name="Text 3"/>
+          <p:cNvSpPr txBox="1"/>
+          <p:nvPr/>
+        </p:nvSpPr>
+        <p:spPr>
+          <a:xfrm>
+            <a:off x="548640" y="3429000"/>
+            <a:ext cx="457200" cy="256032"/>
+          </a:xfrm>
+          <a:prstGeom prst="rect">
+            <a:avLst/>
+          </a:prstGeom>
+          <a:noFill/>
+          <a:ln/>
+        </p:spPr>
+        <p:txBody>
+          <a:bodyPr wrap="square" lIns="0" tIns="0" rIns="0" bIns="0" rtlCol="0" anchor="ctr"/>
+          <a:lstStyle/>
+          <a:p>
+            <a:pPr indent="0" marL="0">
+              <a:buNone/>
+            </a:pPr>
+            <a:r>
+              <a:rPr lang="en-US" sz="1200" b="1" dirty="0">
+                <a:solidFill>
+                  <a:srgbClr val="595959"/>
+                </a:solidFill>
+                <a:latin typeface="Arial" pitchFamily="34" charset="0"/>
+                <a:ea typeface="Arial" pitchFamily="34" charset="-122"/>
+                <a:cs typeface="Arial" pitchFamily="34" charset="-120"/>
+              </a:rPr>
+              <a:t>01</a:t>
+            </a:r>
+            <a:endParaRPr lang="en-US" sz="1200" dirty="0"/>
+          </a:p>
+        </p:txBody>
+      </p:sp>
+      <p:sp>
+        <p:nvSpPr>
+          <p:cNvPr id="7" name="Text 4"/>
+          <p:cNvSpPr txBox="1"/>
+          <p:nvPr/>
+        </p:nvSpPr>
+        <p:spPr>
+          <a:xfrm>
+            <a:off x="1005840" y="3429000"/>
+            <a:ext cx="2743200" cy="256032"/>
+          </a:xfrm>
+          <a:prstGeom prst="rect">
+            <a:avLst/>
+          </a:prstGeom>
+          <a:noFill/>
+          <a:ln/>
+        </p:spPr>
+        <p:txBody>
+          <a:bodyPr wrap="square" lIns="0" tIns="0" rIns="0" bIns="0" rtlCol="0" anchor="ctr"/>
+          <a:lstStyle/>
+          <a:p>
+            <a:pPr indent="0" marL="0">
+              <a:buNone/>
+            </a:pPr>
+            <a:r>
+              <a:rPr lang="en-US" sz="1200" dirty="0">
+                <a:solidFill>
+                  <a:srgbClr val="595959"/>
+                </a:solidFill>
+                <a:latin typeface="Arial" pitchFamily="34" charset="0"/>
+                <a:ea typeface="Arial" pitchFamily="34" charset="-122"/>
+                <a:cs typeface="Arial" pitchFamily="34" charset="-120"/>
+              </a:rPr>
+              <a:t>Empathize</a:t>
+            </a:r>
+            <a:endParaRPr lang="en-US" sz="1200" dirty="0"/>
+          </a:p>
+        </p:txBody>
+      </p:sp>
+      <p:sp>
+        <p:nvSpPr>
+          <p:cNvPr id="8" name="Text 5"/>
+          <p:cNvSpPr txBox="1"/>
+          <p:nvPr/>
+        </p:nvSpPr>
+        <p:spPr>
+          <a:xfrm>
+            <a:off x="548640" y="3685032"/>
+            <a:ext cx="457200" cy="256032"/>
+          </a:xfrm>
+          <a:prstGeom prst="rect">
+            <a:avLst/>
+          </a:prstGeom>
+          <a:noFill/>
+          <a:ln/>
+        </p:spPr>
+        <p:txBody>
+          <a:bodyPr wrap="square" lIns="0" tIns="0" rIns="0" bIns="0" rtlCol="0" anchor="ctr"/>
+          <a:lstStyle/>
+          <a:p>
+            <a:pPr indent="0" marL="0">
+              <a:buNone/>
+            </a:pPr>
+            <a:r>
+              <a:rPr lang="en-US" sz="1200" b="1" dirty="0">
+                <a:solidFill>
+                  <a:srgbClr val="595959"/>
+                </a:solidFill>
+                <a:latin typeface="Arial" pitchFamily="34" charset="0"/>
+                <a:ea typeface="Arial" pitchFamily="34" charset="-122"/>
+                <a:cs typeface="Arial" pitchFamily="34" charset="-120"/>
+              </a:rPr>
+              <a:t>02</a:t>
+            </a:r>
+            <a:endParaRPr lang="en-US" sz="1200" dirty="0"/>
+          </a:p>
+        </p:txBody>
+      </p:sp>
+      <p:sp>
+        <p:nvSpPr>
+          <p:cNvPr id="9" name="Text 6"/>
+          <p:cNvSpPr txBox="1"/>
+          <p:nvPr/>
+        </p:nvSpPr>
+        <p:spPr>
+          <a:xfrm>
+            <a:off x="1005840" y="3685032"/>
+            <a:ext cx="2743200" cy="256032"/>
+          </a:xfrm>
+          <a:prstGeom prst="rect">
+            <a:avLst/>
+          </a:prstGeom>
+          <a:noFill/>
+          <a:ln/>
+        </p:spPr>
+        <p:txBody>
+          <a:bodyPr wrap="square" lIns="0" tIns="0" rIns="0" bIns="0" rtlCol="0" anchor="ctr"/>
+          <a:lstStyle/>
+          <a:p>
+            <a:pPr indent="0" marL="0">
+              <a:buNone/>
+            </a:pPr>
+            <a:r>
+              <a:rPr lang="en-US" sz="1200" dirty="0">
+                <a:solidFill>
+                  <a:srgbClr val="595959"/>
+                </a:solidFill>
+                <a:latin typeface="Arial" pitchFamily="34" charset="0"/>
+                <a:ea typeface="Arial" pitchFamily="34" charset="-122"/>
+                <a:cs typeface="Arial" pitchFamily="34" charset="-120"/>
+              </a:rPr>
+              <a:t>Define</a:t>
+            </a:r>
+            <a:endParaRPr lang="en-US" sz="1200" dirty="0"/>
+          </a:p>
+        </p:txBody>
+      </p:sp>
+      <p:sp>
+        <p:nvSpPr>
+          <p:cNvPr id="10" name="Text 7"/>
+          <p:cNvSpPr txBox="1"/>
+          <p:nvPr/>
+        </p:nvSpPr>
+        <p:spPr>
+          <a:xfrm>
+            <a:off x="548640" y="3941064"/>
+            <a:ext cx="457200" cy="256032"/>
+          </a:xfrm>
+          <a:prstGeom prst="rect">
+            <a:avLst/>
+          </a:prstGeom>
+          <a:noFill/>
+          <a:ln/>
+        </p:spPr>
+        <p:txBody>
+          <a:bodyPr wrap="square" lIns="0" tIns="0" rIns="0" bIns="0" rtlCol="0" anchor="ctr"/>
+          <a:lstStyle/>
+          <a:p>
+            <a:pPr indent="0" marL="0">
+              <a:buNone/>
+            </a:pPr>
+            <a:r>
+              <a:rPr lang="en-US" sz="1200" b="1" dirty="0">
+                <a:solidFill>
+                  <a:srgbClr val="FFFFFF"/>
+                </a:solidFill>
+                <a:latin typeface="Arial" pitchFamily="34" charset="0"/>
+                <a:ea typeface="Arial" pitchFamily="34" charset="-122"/>
+                <a:cs typeface="Arial" pitchFamily="34" charset="-120"/>
+              </a:rPr>
+              <a:t>03</a:t>
+            </a:r>
+            <a:endParaRPr lang="en-US" sz="1200" dirty="0"/>
+          </a:p>
+        </p:txBody>
+      </p:sp>
+      <p:sp>
+        <p:nvSpPr>
+          <p:cNvPr id="11" name="Text 8"/>
+          <p:cNvSpPr txBox="1"/>
+          <p:nvPr/>
+        </p:nvSpPr>
+        <p:spPr>
+          <a:xfrm>
+            <a:off x="1005840" y="3941064"/>
+            <a:ext cx="2743200" cy="256032"/>
+          </a:xfrm>
+          <a:prstGeom prst="rect">
+            <a:avLst/>
+          </a:prstGeom>
+          <a:noFill/>
+          <a:ln/>
+        </p:spPr>
+        <p:txBody>
+          <a:bodyPr wrap="square" lIns="0" tIns="0" rIns="0" bIns="0" rtlCol="0" anchor="ctr"/>
+          <a:lstStyle/>
+          <a:p>
+            <a:pPr indent="0" marL="0">
+              <a:buNone/>
+            </a:pPr>
+            <a:r>
+              <a:rPr lang="en-US" sz="1200" b="1" dirty="0">
+                <a:solidFill>
+                  <a:srgbClr val="FFFFFF"/>
+                </a:solidFill>
+                <a:latin typeface="Arial" pitchFamily="34" charset="0"/>
+                <a:ea typeface="Arial" pitchFamily="34" charset="-122"/>
+                <a:cs typeface="Arial" pitchFamily="34" charset="-120"/>
+              </a:rPr>
+              <a:t>Ideate</a:t>
+            </a:r>
+            <a:endParaRPr lang="en-US" sz="1200" dirty="0"/>
+          </a:p>
+        </p:txBody>
+      </p:sp>
+      <p:sp>
+        <p:nvSpPr>
+          <p:cNvPr id="12" name="Text 9"/>
+          <p:cNvSpPr txBox="1"/>
+          <p:nvPr/>
+        </p:nvSpPr>
+        <p:spPr>
+          <a:xfrm>
+            <a:off x="548640" y="4197096"/>
+            <a:ext cx="457200" cy="256032"/>
+          </a:xfrm>
+          <a:prstGeom prst="rect">
+            <a:avLst/>
+          </a:prstGeom>
+          <a:noFill/>
+          <a:ln/>
+        </p:spPr>
+        <p:txBody>
+          <a:bodyPr wrap="square" lIns="0" tIns="0" rIns="0" bIns="0" rtlCol="0" anchor="ctr"/>
+          <a:lstStyle/>
+          <a:p>
+            <a:pPr indent="0" marL="0">
+              <a:buNone/>
+            </a:pPr>
+            <a:r>
+              <a:rPr lang="en-US" sz="1200" b="1" dirty="0">
+                <a:solidFill>
+                  <a:srgbClr val="595959"/>
+                </a:solidFill>
+                <a:latin typeface="Arial" pitchFamily="34" charset="0"/>
+                <a:ea typeface="Arial" pitchFamily="34" charset="-122"/>
+                <a:cs typeface="Arial" pitchFamily="34" charset="-120"/>
+              </a:rPr>
+              <a:t>04</a:t>
+            </a:r>
+            <a:endParaRPr lang="en-US" sz="1200" dirty="0"/>
+          </a:p>
+        </p:txBody>
+      </p:sp>
+      <p:sp>
+        <p:nvSpPr>
+          <p:cNvPr id="13" name="Text 10"/>
+          <p:cNvSpPr txBox="1"/>
+          <p:nvPr/>
+        </p:nvSpPr>
+        <p:spPr>
+          <a:xfrm>
+            <a:off x="1005840" y="4197096"/>
+            <a:ext cx="2743200" cy="256032"/>
+          </a:xfrm>
+          <a:prstGeom prst="rect">
+            <a:avLst/>
+          </a:prstGeom>
+          <a:noFill/>
+          <a:ln/>
+        </p:spPr>
+        <p:txBody>
+          <a:bodyPr wrap="square" lIns="0" tIns="0" rIns="0" bIns="0" rtlCol="0" anchor="ctr"/>
+          <a:lstStyle/>
+          <a:p>
+            <a:pPr indent="0" marL="0">
+              <a:buNone/>
+            </a:pPr>
+            <a:r>
+              <a:rPr lang="en-US" sz="1200" dirty="0">
+                <a:solidFill>
+                  <a:srgbClr val="595959"/>
+                </a:solidFill>
+                <a:latin typeface="Arial" pitchFamily="34" charset="0"/>
+                <a:ea typeface="Arial" pitchFamily="34" charset="-122"/>
+                <a:cs typeface="Arial" pitchFamily="34" charset="-120"/>
+              </a:rPr>
+              <a:t>Prototype</a:t>
+            </a:r>
+            <a:endParaRPr lang="en-US" sz="1200" dirty="0"/>
+          </a:p>
+        </p:txBody>
+      </p:sp>
+      <p:sp>
+        <p:nvSpPr>
+          <p:cNvPr id="14" name="Text 11"/>
+          <p:cNvSpPr txBox="1"/>
+          <p:nvPr/>
+        </p:nvSpPr>
+        <p:spPr>
+          <a:xfrm>
+            <a:off x="548640" y="4453128"/>
+            <a:ext cx="457200" cy="256032"/>
+          </a:xfrm>
+          <a:prstGeom prst="rect">
+            <a:avLst/>
+          </a:prstGeom>
+          <a:noFill/>
+          <a:ln/>
+        </p:spPr>
+        <p:txBody>
+          <a:bodyPr wrap="square" lIns="0" tIns="0" rIns="0" bIns="0" rtlCol="0" anchor="ctr"/>
+          <a:lstStyle/>
+          <a:p>
+            <a:pPr indent="0" marL="0">
+              <a:buNone/>
+            </a:pPr>
+            <a:r>
+              <a:rPr lang="en-US" sz="1200" b="1" dirty="0">
+                <a:solidFill>
+                  <a:srgbClr val="595959"/>
+                </a:solidFill>
+                <a:latin typeface="Arial" pitchFamily="34" charset="0"/>
+                <a:ea typeface="Arial" pitchFamily="34" charset="-122"/>
+                <a:cs typeface="Arial" pitchFamily="34" charset="-120"/>
+              </a:rPr>
+              <a:t>05</a:t>
+            </a:r>
+            <a:endParaRPr lang="en-US" sz="1200" dirty="0"/>
+          </a:p>
+        </p:txBody>
+      </p:sp>
+      <p:sp>
+        <p:nvSpPr>
+          <p:cNvPr id="15" name="Text 12"/>
+          <p:cNvSpPr txBox="1"/>
+          <p:nvPr/>
+        </p:nvSpPr>
+        <p:spPr>
+          <a:xfrm>
+            <a:off x="1005840" y="4453128"/>
+            <a:ext cx="2743200" cy="256032"/>
+          </a:xfrm>
+          <a:prstGeom prst="rect">
+            <a:avLst/>
+          </a:prstGeom>
+          <a:noFill/>
+          <a:ln/>
+        </p:spPr>
+        <p:txBody>
+          <a:bodyPr wrap="square" lIns="0" tIns="0" rIns="0" bIns="0" rtlCol="0" anchor="ctr"/>
+          <a:lstStyle/>
+          <a:p>
+            <a:pPr indent="0" marL="0">
+              <a:buNone/>
+            </a:pPr>
+            <a:r>
+              <a:rPr lang="en-US" sz="1200" dirty="0">
+                <a:solidFill>
+                  <a:srgbClr val="595959"/>
+                </a:solidFill>
+                <a:latin typeface="Arial" pitchFamily="34" charset="0"/>
+                <a:ea typeface="Arial" pitchFamily="34" charset="-122"/>
+                <a:cs typeface="Arial" pitchFamily="34" charset="-120"/>
+              </a:rPr>
+              <a:t>Test</a:t>
+            </a:r>
+            <a:endParaRPr lang="en-US" sz="1200" dirty="0"/>
+          </a:p>
+        </p:txBody>
+      </p:sp>
+      <p:sp>
+        <p:nvSpPr>
+          <p:cNvPr id="16" name="Shape 13"/>
           <p:cNvSpPr/>
           <p:nvPr/>
         </p:nvSpPr>
@@ -3657,7 +4086,7 @@
       </p:sp>
       <p:sp>
         <p:nvSpPr>
-          <p:cNvPr id="7" name="Text 4"/>
+          <p:cNvPr id="17" name="Text 14"/>
           <p:cNvSpPr txBox="1"/>
           <p:nvPr/>
         </p:nvSpPr>
@@ -3696,14 +4125,14 @@
       </p:sp>
       <p:sp>
         <p:nvSpPr>
-          <p:cNvPr id="8" name="Text 5"/>
-          <p:cNvSpPr txBox="1"/>
-          <p:nvPr/>
-        </p:nvSpPr>
-        <p:spPr>
-          <a:xfrm>
-            <a:off x="4754880" y="960120"/>
-            <a:ext cx="3657600" cy="960120"/>
+          <p:cNvPr id="18" name="Text 15"/>
+          <p:cNvSpPr txBox="1"/>
+          <p:nvPr/>
+        </p:nvSpPr>
+        <p:spPr>
+          <a:xfrm>
+            <a:off x="4754880" y="978408"/>
+            <a:ext cx="3657600" cy="1005840"/>
           </a:xfrm>
           <a:prstGeom prst="rect">
             <a:avLst/>
@@ -3719,7 +4148,7 @@
               <a:buNone/>
             </a:pPr>
             <a:r>
-              <a:rPr lang="en-US" sz="1400" dirty="0">
+              <a:rPr lang="en-US" sz="1500" dirty="0">
                 <a:solidFill>
                   <a:srgbClr val="000000"/>
                 </a:solidFill>
@@ -3729,13 +4158,13 @@
               </a:rPr>
               <a:t>Come up with as many possible solutions as you can, even bad ones. Only after that, pick the best.</a:t>
             </a:r>
-            <a:endParaRPr lang="en-US" sz="1400" dirty="0"/>
-          </a:p>
-        </p:txBody>
-      </p:sp>
-      <p:sp>
-        <p:nvSpPr>
-          <p:cNvPr id="9" name="Text 6"/>
+            <a:endParaRPr lang="en-US" sz="1500" dirty="0"/>
+          </a:p>
+        </p:txBody>
+      </p:sp>
+      <p:sp>
+        <p:nvSpPr>
+          <p:cNvPr id="19" name="Text 16"/>
           <p:cNvSpPr txBox="1"/>
           <p:nvPr/>
         </p:nvSpPr>
@@ -3774,14 +4203,14 @@
       </p:sp>
       <p:sp>
         <p:nvSpPr>
-          <p:cNvPr id="10" name="Text 7"/>
-          <p:cNvSpPr txBox="1"/>
-          <p:nvPr/>
-        </p:nvSpPr>
-        <p:spPr>
-          <a:xfrm>
-            <a:off x="4754880" y="2331720"/>
-            <a:ext cx="3657600" cy="960120"/>
+          <p:cNvPr id="20" name="Text 17"/>
+          <p:cNvSpPr txBox="1"/>
+          <p:nvPr/>
+        </p:nvSpPr>
+        <p:spPr>
+          <a:xfrm>
+            <a:off x="4754880" y="2350008"/>
+            <a:ext cx="3657600" cy="1005840"/>
           </a:xfrm>
           <a:prstGeom prst="rect">
             <a:avLst/>
@@ -3797,7 +4226,7 @@
               <a:buNone/>
             </a:pPr>
             <a:r>
-              <a:rPr lang="en-US" sz="1400" dirty="0">
+              <a:rPr lang="en-US" sz="1500" dirty="0">
                 <a:solidFill>
                   <a:srgbClr val="000000"/>
                 </a:solidFill>
@@ -3807,13 +4236,13 @@
               </a:rPr>
               <a:t>What are all the ways we could solve this?</a:t>
             </a:r>
-            <a:endParaRPr lang="en-US" sz="1400" dirty="0"/>
-          </a:p>
-        </p:txBody>
-      </p:sp>
-      <p:sp>
-        <p:nvSpPr>
-          <p:cNvPr id="11" name="Text 8"/>
+            <a:endParaRPr lang="en-US" sz="1500" dirty="0"/>
+          </a:p>
+        </p:txBody>
+      </p:sp>
+      <p:sp>
+        <p:nvSpPr>
+          <p:cNvPr id="21" name="Text 18"/>
           <p:cNvSpPr txBox="1"/>
           <p:nvPr/>
         </p:nvSpPr>
@@ -3852,14 +4281,14 @@
       </p:sp>
       <p:sp>
         <p:nvSpPr>
-          <p:cNvPr id="12" name="Text 9"/>
-          <p:cNvSpPr txBox="1"/>
-          <p:nvPr/>
-        </p:nvSpPr>
-        <p:spPr>
-          <a:xfrm>
-            <a:off x="4754880" y="3703320"/>
-            <a:ext cx="3657600" cy="960120"/>
+          <p:cNvPr id="22" name="Text 19"/>
+          <p:cNvSpPr txBox="1"/>
+          <p:nvPr/>
+        </p:nvSpPr>
+        <p:spPr>
+          <a:xfrm>
+            <a:off x="4754880" y="3721608"/>
+            <a:ext cx="3657600" cy="1005840"/>
           </a:xfrm>
           <a:prstGeom prst="rect">
             <a:avLst/>
@@ -3875,7 +4304,7 @@
               <a:buNone/>
             </a:pPr>
             <a:r>
-              <a:rPr lang="en-US" sz="1400" dirty="0">
+              <a:rPr lang="en-US" sz="1500" dirty="0">
                 <a:solidFill>
                   <a:srgbClr val="000000"/>
                 </a:solidFill>
@@ -3885,7 +4314,7 @@
               </a:rPr>
               <a:t>listed six different ideas, tested the promising ones, and dropped four with honest reasons.</a:t>
             </a:r>
-            <a:endParaRPr lang="en-US" sz="1400" dirty="0"/>
+            <a:endParaRPr lang="en-US" sz="1500" dirty="0"/>
           </a:p>
         </p:txBody>
       </p:sp>
@@ -5725,8 +6154,8 @@
         </p:nvSpPr>
         <p:spPr>
           <a:xfrm>
-            <a:off x="548640" y="2697480"/>
-            <a:ext cx="3474720" cy="914400"/>
+            <a:off x="548640" y="2560320"/>
+            <a:ext cx="3474720" cy="640080"/>
           </a:xfrm>
           <a:prstGeom prst="rect">
             <a:avLst/>
@@ -5742,7 +6171,7 @@
               <a:buNone/>
             </a:pPr>
             <a:r>
-              <a:rPr lang="en-US" sz="1800" i="1" dirty="0">
+              <a:rPr lang="en-US" sz="1600" i="1" dirty="0">
                 <a:solidFill>
                   <a:srgbClr val="BFBFBF"/>
                 </a:solidFill>
@@ -5752,13 +6181,403 @@
               </a:rPr>
               <a:t>Build it fast, build it real.</a:t>
             </a:r>
-            <a:endParaRPr lang="en-US" sz="1800" dirty="0"/>
-          </a:p>
-        </p:txBody>
-      </p:sp>
-      <p:sp>
-        <p:nvSpPr>
-          <p:cNvPr id="6" name="Shape 3"/>
+            <a:endParaRPr lang="en-US" sz="1600" dirty="0"/>
+          </a:p>
+        </p:txBody>
+      </p:sp>
+      <p:sp>
+        <p:nvSpPr>
+          <p:cNvPr id="6" name="Text 3"/>
+          <p:cNvSpPr txBox="1"/>
+          <p:nvPr/>
+        </p:nvSpPr>
+        <p:spPr>
+          <a:xfrm>
+            <a:off x="548640" y="3429000"/>
+            <a:ext cx="457200" cy="256032"/>
+          </a:xfrm>
+          <a:prstGeom prst="rect">
+            <a:avLst/>
+          </a:prstGeom>
+          <a:noFill/>
+          <a:ln/>
+        </p:spPr>
+        <p:txBody>
+          <a:bodyPr wrap="square" lIns="0" tIns="0" rIns="0" bIns="0" rtlCol="0" anchor="ctr"/>
+          <a:lstStyle/>
+          <a:p>
+            <a:pPr indent="0" marL="0">
+              <a:buNone/>
+            </a:pPr>
+            <a:r>
+              <a:rPr lang="en-US" sz="1200" b="1" dirty="0">
+                <a:solidFill>
+                  <a:srgbClr val="595959"/>
+                </a:solidFill>
+                <a:latin typeface="Arial" pitchFamily="34" charset="0"/>
+                <a:ea typeface="Arial" pitchFamily="34" charset="-122"/>
+                <a:cs typeface="Arial" pitchFamily="34" charset="-120"/>
+              </a:rPr>
+              <a:t>01</a:t>
+            </a:r>
+            <a:endParaRPr lang="en-US" sz="1200" dirty="0"/>
+          </a:p>
+        </p:txBody>
+      </p:sp>
+      <p:sp>
+        <p:nvSpPr>
+          <p:cNvPr id="7" name="Text 4"/>
+          <p:cNvSpPr txBox="1"/>
+          <p:nvPr/>
+        </p:nvSpPr>
+        <p:spPr>
+          <a:xfrm>
+            <a:off x="1005840" y="3429000"/>
+            <a:ext cx="2743200" cy="256032"/>
+          </a:xfrm>
+          <a:prstGeom prst="rect">
+            <a:avLst/>
+          </a:prstGeom>
+          <a:noFill/>
+          <a:ln/>
+        </p:spPr>
+        <p:txBody>
+          <a:bodyPr wrap="square" lIns="0" tIns="0" rIns="0" bIns="0" rtlCol="0" anchor="ctr"/>
+          <a:lstStyle/>
+          <a:p>
+            <a:pPr indent="0" marL="0">
+              <a:buNone/>
+            </a:pPr>
+            <a:r>
+              <a:rPr lang="en-US" sz="1200" dirty="0">
+                <a:solidFill>
+                  <a:srgbClr val="595959"/>
+                </a:solidFill>
+                <a:latin typeface="Arial" pitchFamily="34" charset="0"/>
+                <a:ea typeface="Arial" pitchFamily="34" charset="-122"/>
+                <a:cs typeface="Arial" pitchFamily="34" charset="-120"/>
+              </a:rPr>
+              <a:t>Empathize</a:t>
+            </a:r>
+            <a:endParaRPr lang="en-US" sz="1200" dirty="0"/>
+          </a:p>
+        </p:txBody>
+      </p:sp>
+      <p:sp>
+        <p:nvSpPr>
+          <p:cNvPr id="8" name="Text 5"/>
+          <p:cNvSpPr txBox="1"/>
+          <p:nvPr/>
+        </p:nvSpPr>
+        <p:spPr>
+          <a:xfrm>
+            <a:off x="548640" y="3685032"/>
+            <a:ext cx="457200" cy="256032"/>
+          </a:xfrm>
+          <a:prstGeom prst="rect">
+            <a:avLst/>
+          </a:prstGeom>
+          <a:noFill/>
+          <a:ln/>
+        </p:spPr>
+        <p:txBody>
+          <a:bodyPr wrap="square" lIns="0" tIns="0" rIns="0" bIns="0" rtlCol="0" anchor="ctr"/>
+          <a:lstStyle/>
+          <a:p>
+            <a:pPr indent="0" marL="0">
+              <a:buNone/>
+            </a:pPr>
+            <a:r>
+              <a:rPr lang="en-US" sz="1200" b="1" dirty="0">
+                <a:solidFill>
+                  <a:srgbClr val="595959"/>
+                </a:solidFill>
+                <a:latin typeface="Arial" pitchFamily="34" charset="0"/>
+                <a:ea typeface="Arial" pitchFamily="34" charset="-122"/>
+                <a:cs typeface="Arial" pitchFamily="34" charset="-120"/>
+              </a:rPr>
+              <a:t>02</a:t>
+            </a:r>
+            <a:endParaRPr lang="en-US" sz="1200" dirty="0"/>
+          </a:p>
+        </p:txBody>
+      </p:sp>
+      <p:sp>
+        <p:nvSpPr>
+          <p:cNvPr id="9" name="Text 6"/>
+          <p:cNvSpPr txBox="1"/>
+          <p:nvPr/>
+        </p:nvSpPr>
+        <p:spPr>
+          <a:xfrm>
+            <a:off x="1005840" y="3685032"/>
+            <a:ext cx="2743200" cy="256032"/>
+          </a:xfrm>
+          <a:prstGeom prst="rect">
+            <a:avLst/>
+          </a:prstGeom>
+          <a:noFill/>
+          <a:ln/>
+        </p:spPr>
+        <p:txBody>
+          <a:bodyPr wrap="square" lIns="0" tIns="0" rIns="0" bIns="0" rtlCol="0" anchor="ctr"/>
+          <a:lstStyle/>
+          <a:p>
+            <a:pPr indent="0" marL="0">
+              <a:buNone/>
+            </a:pPr>
+            <a:r>
+              <a:rPr lang="en-US" sz="1200" dirty="0">
+                <a:solidFill>
+                  <a:srgbClr val="595959"/>
+                </a:solidFill>
+                <a:latin typeface="Arial" pitchFamily="34" charset="0"/>
+                <a:ea typeface="Arial" pitchFamily="34" charset="-122"/>
+                <a:cs typeface="Arial" pitchFamily="34" charset="-120"/>
+              </a:rPr>
+              <a:t>Define</a:t>
+            </a:r>
+            <a:endParaRPr lang="en-US" sz="1200" dirty="0"/>
+          </a:p>
+        </p:txBody>
+      </p:sp>
+      <p:sp>
+        <p:nvSpPr>
+          <p:cNvPr id="10" name="Text 7"/>
+          <p:cNvSpPr txBox="1"/>
+          <p:nvPr/>
+        </p:nvSpPr>
+        <p:spPr>
+          <a:xfrm>
+            <a:off x="548640" y="3941064"/>
+            <a:ext cx="457200" cy="256032"/>
+          </a:xfrm>
+          <a:prstGeom prst="rect">
+            <a:avLst/>
+          </a:prstGeom>
+          <a:noFill/>
+          <a:ln/>
+        </p:spPr>
+        <p:txBody>
+          <a:bodyPr wrap="square" lIns="0" tIns="0" rIns="0" bIns="0" rtlCol="0" anchor="ctr"/>
+          <a:lstStyle/>
+          <a:p>
+            <a:pPr indent="0" marL="0">
+              <a:buNone/>
+            </a:pPr>
+            <a:r>
+              <a:rPr lang="en-US" sz="1200" b="1" dirty="0">
+                <a:solidFill>
+                  <a:srgbClr val="595959"/>
+                </a:solidFill>
+                <a:latin typeface="Arial" pitchFamily="34" charset="0"/>
+                <a:ea typeface="Arial" pitchFamily="34" charset="-122"/>
+                <a:cs typeface="Arial" pitchFamily="34" charset="-120"/>
+              </a:rPr>
+              <a:t>03</a:t>
+            </a:r>
+            <a:endParaRPr lang="en-US" sz="1200" dirty="0"/>
+          </a:p>
+        </p:txBody>
+      </p:sp>
+      <p:sp>
+        <p:nvSpPr>
+          <p:cNvPr id="11" name="Text 8"/>
+          <p:cNvSpPr txBox="1"/>
+          <p:nvPr/>
+        </p:nvSpPr>
+        <p:spPr>
+          <a:xfrm>
+            <a:off x="1005840" y="3941064"/>
+            <a:ext cx="2743200" cy="256032"/>
+          </a:xfrm>
+          <a:prstGeom prst="rect">
+            <a:avLst/>
+          </a:prstGeom>
+          <a:noFill/>
+          <a:ln/>
+        </p:spPr>
+        <p:txBody>
+          <a:bodyPr wrap="square" lIns="0" tIns="0" rIns="0" bIns="0" rtlCol="0" anchor="ctr"/>
+          <a:lstStyle/>
+          <a:p>
+            <a:pPr indent="0" marL="0">
+              <a:buNone/>
+            </a:pPr>
+            <a:r>
+              <a:rPr lang="en-US" sz="1200" dirty="0">
+                <a:solidFill>
+                  <a:srgbClr val="595959"/>
+                </a:solidFill>
+                <a:latin typeface="Arial" pitchFamily="34" charset="0"/>
+                <a:ea typeface="Arial" pitchFamily="34" charset="-122"/>
+                <a:cs typeface="Arial" pitchFamily="34" charset="-120"/>
+              </a:rPr>
+              <a:t>Ideate</a:t>
+            </a:r>
+            <a:endParaRPr lang="en-US" sz="1200" dirty="0"/>
+          </a:p>
+        </p:txBody>
+      </p:sp>
+      <p:sp>
+        <p:nvSpPr>
+          <p:cNvPr id="12" name="Text 9"/>
+          <p:cNvSpPr txBox="1"/>
+          <p:nvPr/>
+        </p:nvSpPr>
+        <p:spPr>
+          <a:xfrm>
+            <a:off x="548640" y="4197096"/>
+            <a:ext cx="457200" cy="256032"/>
+          </a:xfrm>
+          <a:prstGeom prst="rect">
+            <a:avLst/>
+          </a:prstGeom>
+          <a:noFill/>
+          <a:ln/>
+        </p:spPr>
+        <p:txBody>
+          <a:bodyPr wrap="square" lIns="0" tIns="0" rIns="0" bIns="0" rtlCol="0" anchor="ctr"/>
+          <a:lstStyle/>
+          <a:p>
+            <a:pPr indent="0" marL="0">
+              <a:buNone/>
+            </a:pPr>
+            <a:r>
+              <a:rPr lang="en-US" sz="1200" b="1" dirty="0">
+                <a:solidFill>
+                  <a:srgbClr val="FFFFFF"/>
+                </a:solidFill>
+                <a:latin typeface="Arial" pitchFamily="34" charset="0"/>
+                <a:ea typeface="Arial" pitchFamily="34" charset="-122"/>
+                <a:cs typeface="Arial" pitchFamily="34" charset="-120"/>
+              </a:rPr>
+              <a:t>04</a:t>
+            </a:r>
+            <a:endParaRPr lang="en-US" sz="1200" dirty="0"/>
+          </a:p>
+        </p:txBody>
+      </p:sp>
+      <p:sp>
+        <p:nvSpPr>
+          <p:cNvPr id="13" name="Text 10"/>
+          <p:cNvSpPr txBox="1"/>
+          <p:nvPr/>
+        </p:nvSpPr>
+        <p:spPr>
+          <a:xfrm>
+            <a:off x="1005840" y="4197096"/>
+            <a:ext cx="2743200" cy="256032"/>
+          </a:xfrm>
+          <a:prstGeom prst="rect">
+            <a:avLst/>
+          </a:prstGeom>
+          <a:noFill/>
+          <a:ln/>
+        </p:spPr>
+        <p:txBody>
+          <a:bodyPr wrap="square" lIns="0" tIns="0" rIns="0" bIns="0" rtlCol="0" anchor="ctr"/>
+          <a:lstStyle/>
+          <a:p>
+            <a:pPr indent="0" marL="0">
+              <a:buNone/>
+            </a:pPr>
+            <a:r>
+              <a:rPr lang="en-US" sz="1200" b="1" dirty="0">
+                <a:solidFill>
+                  <a:srgbClr val="FFFFFF"/>
+                </a:solidFill>
+                <a:latin typeface="Arial" pitchFamily="34" charset="0"/>
+                <a:ea typeface="Arial" pitchFamily="34" charset="-122"/>
+                <a:cs typeface="Arial" pitchFamily="34" charset="-120"/>
+              </a:rPr>
+              <a:t>Prototype</a:t>
+            </a:r>
+            <a:endParaRPr lang="en-US" sz="1200" dirty="0"/>
+          </a:p>
+        </p:txBody>
+      </p:sp>
+      <p:sp>
+        <p:nvSpPr>
+          <p:cNvPr id="14" name="Text 11"/>
+          <p:cNvSpPr txBox="1"/>
+          <p:nvPr/>
+        </p:nvSpPr>
+        <p:spPr>
+          <a:xfrm>
+            <a:off x="548640" y="4453128"/>
+            <a:ext cx="457200" cy="256032"/>
+          </a:xfrm>
+          <a:prstGeom prst="rect">
+            <a:avLst/>
+          </a:prstGeom>
+          <a:noFill/>
+          <a:ln/>
+        </p:spPr>
+        <p:txBody>
+          <a:bodyPr wrap="square" lIns="0" tIns="0" rIns="0" bIns="0" rtlCol="0" anchor="ctr"/>
+          <a:lstStyle/>
+          <a:p>
+            <a:pPr indent="0" marL="0">
+              <a:buNone/>
+            </a:pPr>
+            <a:r>
+              <a:rPr lang="en-US" sz="1200" b="1" dirty="0">
+                <a:solidFill>
+                  <a:srgbClr val="595959"/>
+                </a:solidFill>
+                <a:latin typeface="Arial" pitchFamily="34" charset="0"/>
+                <a:ea typeface="Arial" pitchFamily="34" charset="-122"/>
+                <a:cs typeface="Arial" pitchFamily="34" charset="-120"/>
+              </a:rPr>
+              <a:t>05</a:t>
+            </a:r>
+            <a:endParaRPr lang="en-US" sz="1200" dirty="0"/>
+          </a:p>
+        </p:txBody>
+      </p:sp>
+      <p:sp>
+        <p:nvSpPr>
+          <p:cNvPr id="15" name="Text 12"/>
+          <p:cNvSpPr txBox="1"/>
+          <p:nvPr/>
+        </p:nvSpPr>
+        <p:spPr>
+          <a:xfrm>
+            <a:off x="1005840" y="4453128"/>
+            <a:ext cx="2743200" cy="256032"/>
+          </a:xfrm>
+          <a:prstGeom prst="rect">
+            <a:avLst/>
+          </a:prstGeom>
+          <a:noFill/>
+          <a:ln/>
+        </p:spPr>
+        <p:txBody>
+          <a:bodyPr wrap="square" lIns="0" tIns="0" rIns="0" bIns="0" rtlCol="0" anchor="ctr"/>
+          <a:lstStyle/>
+          <a:p>
+            <a:pPr indent="0" marL="0">
+              <a:buNone/>
+            </a:pPr>
+            <a:r>
+              <a:rPr lang="en-US" sz="1200" dirty="0">
+                <a:solidFill>
+                  <a:srgbClr val="595959"/>
+                </a:solidFill>
+                <a:latin typeface="Arial" pitchFamily="34" charset="0"/>
+                <a:ea typeface="Arial" pitchFamily="34" charset="-122"/>
+                <a:cs typeface="Arial" pitchFamily="34" charset="-120"/>
+              </a:rPr>
+              <a:t>Test</a:t>
+            </a:r>
+            <a:endParaRPr lang="en-US" sz="1200" dirty="0"/>
+          </a:p>
+        </p:txBody>
+      </p:sp>
+      <p:sp>
+        <p:nvSpPr>
+          <p:cNvPr id="16" name="Shape 13"/>
           <p:cNvSpPr/>
           <p:nvPr/>
         </p:nvSpPr>
@@ -5783,7 +6602,7 @@
       </p:sp>
       <p:sp>
         <p:nvSpPr>
-          <p:cNvPr id="7" name="Text 4"/>
+          <p:cNvPr id="17" name="Text 14"/>
           <p:cNvSpPr txBox="1"/>
           <p:nvPr/>
         </p:nvSpPr>
@@ -5822,14 +6641,14 @@
       </p:sp>
       <p:sp>
         <p:nvSpPr>
-          <p:cNvPr id="8" name="Text 5"/>
-          <p:cNvSpPr txBox="1"/>
-          <p:nvPr/>
-        </p:nvSpPr>
-        <p:spPr>
-          <a:xfrm>
-            <a:off x="4754880" y="960120"/>
-            <a:ext cx="3657600" cy="960120"/>
+          <p:cNvPr id="18" name="Text 15"/>
+          <p:cNvSpPr txBox="1"/>
+          <p:nvPr/>
+        </p:nvSpPr>
+        <p:spPr>
+          <a:xfrm>
+            <a:off x="4754880" y="978408"/>
+            <a:ext cx="3657600" cy="1005840"/>
           </a:xfrm>
           <a:prstGeom prst="rect">
             <a:avLst/>
@@ -5845,7 +6664,7 @@
               <a:buNone/>
             </a:pPr>
             <a:r>
-              <a:rPr lang="en-US" sz="1400" dirty="0">
+              <a:rPr lang="en-US" sz="1500" dirty="0">
                 <a:solidFill>
                   <a:srgbClr val="000000"/>
                 </a:solidFill>
@@ -5855,13 +6674,13 @@
               </a:rPr>
               <a:t>Make the idea into something people can actually use, quickly and cheaply, so you can learn from it.</a:t>
             </a:r>
-            <a:endParaRPr lang="en-US" sz="1400" dirty="0"/>
-          </a:p>
-        </p:txBody>
-      </p:sp>
-      <p:sp>
-        <p:nvSpPr>
-          <p:cNvPr id="9" name="Text 6"/>
+            <a:endParaRPr lang="en-US" sz="1500" dirty="0"/>
+          </a:p>
+        </p:txBody>
+      </p:sp>
+      <p:sp>
+        <p:nvSpPr>
+          <p:cNvPr id="19" name="Text 16"/>
           <p:cNvSpPr txBox="1"/>
           <p:nvPr/>
         </p:nvSpPr>
@@ -5900,14 +6719,14 @@
       </p:sp>
       <p:sp>
         <p:nvSpPr>
-          <p:cNvPr id="10" name="Text 7"/>
-          <p:cNvSpPr txBox="1"/>
-          <p:nvPr/>
-        </p:nvSpPr>
-        <p:spPr>
-          <a:xfrm>
-            <a:off x="4754880" y="2331720"/>
-            <a:ext cx="3657600" cy="960120"/>
+          <p:cNvPr id="20" name="Text 17"/>
+          <p:cNvSpPr txBox="1"/>
+          <p:nvPr/>
+        </p:nvSpPr>
+        <p:spPr>
+          <a:xfrm>
+            <a:off x="4754880" y="2350008"/>
+            <a:ext cx="3657600" cy="1005840"/>
           </a:xfrm>
           <a:prstGeom prst="rect">
             <a:avLst/>
@@ -5923,7 +6742,7 @@
               <a:buNone/>
             </a:pPr>
             <a:r>
-              <a:rPr lang="en-US" sz="1400" dirty="0">
+              <a:rPr lang="en-US" sz="1500" dirty="0">
                 <a:solidFill>
                   <a:srgbClr val="000000"/>
                 </a:solidFill>
@@ -5933,13 +6752,13 @@
               </a:rPr>
               <a:t>Can we build a working version to try?</a:t>
             </a:r>
-            <a:endParaRPr lang="en-US" sz="1400" dirty="0"/>
-          </a:p>
-        </p:txBody>
-      </p:sp>
-      <p:sp>
-        <p:nvSpPr>
-          <p:cNvPr id="11" name="Text 8"/>
+            <a:endParaRPr lang="en-US" sz="1500" dirty="0"/>
+          </a:p>
+        </p:txBody>
+      </p:sp>
+      <p:sp>
+        <p:nvSpPr>
+          <p:cNvPr id="21" name="Text 18"/>
           <p:cNvSpPr txBox="1"/>
           <p:nvPr/>
         </p:nvSpPr>
@@ -5978,14 +6797,14 @@
       </p:sp>
       <p:sp>
         <p:nvSpPr>
-          <p:cNvPr id="12" name="Text 9"/>
-          <p:cNvSpPr txBox="1"/>
-          <p:nvPr/>
-        </p:nvSpPr>
-        <p:spPr>
-          <a:xfrm>
-            <a:off x="4754880" y="3703320"/>
-            <a:ext cx="3657600" cy="960120"/>
+          <p:cNvPr id="22" name="Text 19"/>
+          <p:cNvSpPr txBox="1"/>
+          <p:nvPr/>
+        </p:nvSpPr>
+        <p:spPr>
+          <a:xfrm>
+            <a:off x="4754880" y="3721608"/>
+            <a:ext cx="3657600" cy="1005840"/>
           </a:xfrm>
           <a:prstGeom prst="rect">
             <a:avLst/>
@@ -6001,7 +6820,7 @@
               <a:buNone/>
             </a:pPr>
             <a:r>
-              <a:rPr lang="en-US" sz="1400" dirty="0">
+              <a:rPr lang="en-US" sz="1500" dirty="0">
                 <a:solidFill>
                   <a:srgbClr val="000000"/>
                 </a:solidFill>
@@ -6011,7 +6830,7 @@
               </a:rPr>
               <a:t>built a working proxy, a command line tool and a desktop app, not just a mock-up.</a:t>
             </a:r>
-            <a:endParaRPr lang="en-US" sz="1400" dirty="0"/>
+            <a:endParaRPr lang="en-US" sz="1500" dirty="0"/>
           </a:p>
         </p:txBody>
       </p:sp>
@@ -7581,8 +8400,8 @@
         </p:nvSpPr>
         <p:spPr>
           <a:xfrm>
-            <a:off x="548640" y="2697480"/>
-            <a:ext cx="3474720" cy="914400"/>
+            <a:off x="548640" y="2560320"/>
+            <a:ext cx="3474720" cy="640080"/>
           </a:xfrm>
           <a:prstGeom prst="rect">
             <a:avLst/>
@@ -7598,7 +8417,7 @@
               <a:buNone/>
             </a:pPr>
             <a:r>
-              <a:rPr lang="en-US" sz="1800" i="1" dirty="0">
+              <a:rPr lang="en-US" sz="1600" i="1" dirty="0">
                 <a:solidFill>
                   <a:srgbClr val="BFBFBF"/>
                 </a:solidFill>
@@ -7608,13 +8427,403 @@
               </a:rPr>
               <a:t>Measure honestly, even the bad news.</a:t>
             </a:r>
-            <a:endParaRPr lang="en-US" sz="1800" dirty="0"/>
-          </a:p>
-        </p:txBody>
-      </p:sp>
-      <p:sp>
-        <p:nvSpPr>
-          <p:cNvPr id="6" name="Shape 3"/>
+            <a:endParaRPr lang="en-US" sz="1600" dirty="0"/>
+          </a:p>
+        </p:txBody>
+      </p:sp>
+      <p:sp>
+        <p:nvSpPr>
+          <p:cNvPr id="6" name="Text 3"/>
+          <p:cNvSpPr txBox="1"/>
+          <p:nvPr/>
+        </p:nvSpPr>
+        <p:spPr>
+          <a:xfrm>
+            <a:off x="548640" y="3429000"/>
+            <a:ext cx="457200" cy="256032"/>
+          </a:xfrm>
+          <a:prstGeom prst="rect">
+            <a:avLst/>
+          </a:prstGeom>
+          <a:noFill/>
+          <a:ln/>
+        </p:spPr>
+        <p:txBody>
+          <a:bodyPr wrap="square" lIns="0" tIns="0" rIns="0" bIns="0" rtlCol="0" anchor="ctr"/>
+          <a:lstStyle/>
+          <a:p>
+            <a:pPr indent="0" marL="0">
+              <a:buNone/>
+            </a:pPr>
+            <a:r>
+              <a:rPr lang="en-US" sz="1200" b="1" dirty="0">
+                <a:solidFill>
+                  <a:srgbClr val="595959"/>
+                </a:solidFill>
+                <a:latin typeface="Arial" pitchFamily="34" charset="0"/>
+                <a:ea typeface="Arial" pitchFamily="34" charset="-122"/>
+                <a:cs typeface="Arial" pitchFamily="34" charset="-120"/>
+              </a:rPr>
+              <a:t>01</a:t>
+            </a:r>
+            <a:endParaRPr lang="en-US" sz="1200" dirty="0"/>
+          </a:p>
+        </p:txBody>
+      </p:sp>
+      <p:sp>
+        <p:nvSpPr>
+          <p:cNvPr id="7" name="Text 4"/>
+          <p:cNvSpPr txBox="1"/>
+          <p:nvPr/>
+        </p:nvSpPr>
+        <p:spPr>
+          <a:xfrm>
+            <a:off x="1005840" y="3429000"/>
+            <a:ext cx="2743200" cy="256032"/>
+          </a:xfrm>
+          <a:prstGeom prst="rect">
+            <a:avLst/>
+          </a:prstGeom>
+          <a:noFill/>
+          <a:ln/>
+        </p:spPr>
+        <p:txBody>
+          <a:bodyPr wrap="square" lIns="0" tIns="0" rIns="0" bIns="0" rtlCol="0" anchor="ctr"/>
+          <a:lstStyle/>
+          <a:p>
+            <a:pPr indent="0" marL="0">
+              <a:buNone/>
+            </a:pPr>
+            <a:r>
+              <a:rPr lang="en-US" sz="1200" dirty="0">
+                <a:solidFill>
+                  <a:srgbClr val="595959"/>
+                </a:solidFill>
+                <a:latin typeface="Arial" pitchFamily="34" charset="0"/>
+                <a:ea typeface="Arial" pitchFamily="34" charset="-122"/>
+                <a:cs typeface="Arial" pitchFamily="34" charset="-120"/>
+              </a:rPr>
+              <a:t>Empathize</a:t>
+            </a:r>
+            <a:endParaRPr lang="en-US" sz="1200" dirty="0"/>
+          </a:p>
+        </p:txBody>
+      </p:sp>
+      <p:sp>
+        <p:nvSpPr>
+          <p:cNvPr id="8" name="Text 5"/>
+          <p:cNvSpPr txBox="1"/>
+          <p:nvPr/>
+        </p:nvSpPr>
+        <p:spPr>
+          <a:xfrm>
+            <a:off x="548640" y="3685032"/>
+            <a:ext cx="457200" cy="256032"/>
+          </a:xfrm>
+          <a:prstGeom prst="rect">
+            <a:avLst/>
+          </a:prstGeom>
+          <a:noFill/>
+          <a:ln/>
+        </p:spPr>
+        <p:txBody>
+          <a:bodyPr wrap="square" lIns="0" tIns="0" rIns="0" bIns="0" rtlCol="0" anchor="ctr"/>
+          <a:lstStyle/>
+          <a:p>
+            <a:pPr indent="0" marL="0">
+              <a:buNone/>
+            </a:pPr>
+            <a:r>
+              <a:rPr lang="en-US" sz="1200" b="1" dirty="0">
+                <a:solidFill>
+                  <a:srgbClr val="595959"/>
+                </a:solidFill>
+                <a:latin typeface="Arial" pitchFamily="34" charset="0"/>
+                <a:ea typeface="Arial" pitchFamily="34" charset="-122"/>
+                <a:cs typeface="Arial" pitchFamily="34" charset="-120"/>
+              </a:rPr>
+              <a:t>02</a:t>
+            </a:r>
+            <a:endParaRPr lang="en-US" sz="1200" dirty="0"/>
+          </a:p>
+        </p:txBody>
+      </p:sp>
+      <p:sp>
+        <p:nvSpPr>
+          <p:cNvPr id="9" name="Text 6"/>
+          <p:cNvSpPr txBox="1"/>
+          <p:nvPr/>
+        </p:nvSpPr>
+        <p:spPr>
+          <a:xfrm>
+            <a:off x="1005840" y="3685032"/>
+            <a:ext cx="2743200" cy="256032"/>
+          </a:xfrm>
+          <a:prstGeom prst="rect">
+            <a:avLst/>
+          </a:prstGeom>
+          <a:noFill/>
+          <a:ln/>
+        </p:spPr>
+        <p:txBody>
+          <a:bodyPr wrap="square" lIns="0" tIns="0" rIns="0" bIns="0" rtlCol="0" anchor="ctr"/>
+          <a:lstStyle/>
+          <a:p>
+            <a:pPr indent="0" marL="0">
+              <a:buNone/>
+            </a:pPr>
+            <a:r>
+              <a:rPr lang="en-US" sz="1200" dirty="0">
+                <a:solidFill>
+                  <a:srgbClr val="595959"/>
+                </a:solidFill>
+                <a:latin typeface="Arial" pitchFamily="34" charset="0"/>
+                <a:ea typeface="Arial" pitchFamily="34" charset="-122"/>
+                <a:cs typeface="Arial" pitchFamily="34" charset="-120"/>
+              </a:rPr>
+              <a:t>Define</a:t>
+            </a:r>
+            <a:endParaRPr lang="en-US" sz="1200" dirty="0"/>
+          </a:p>
+        </p:txBody>
+      </p:sp>
+      <p:sp>
+        <p:nvSpPr>
+          <p:cNvPr id="10" name="Text 7"/>
+          <p:cNvSpPr txBox="1"/>
+          <p:nvPr/>
+        </p:nvSpPr>
+        <p:spPr>
+          <a:xfrm>
+            <a:off x="548640" y="3941064"/>
+            <a:ext cx="457200" cy="256032"/>
+          </a:xfrm>
+          <a:prstGeom prst="rect">
+            <a:avLst/>
+          </a:prstGeom>
+          <a:noFill/>
+          <a:ln/>
+        </p:spPr>
+        <p:txBody>
+          <a:bodyPr wrap="square" lIns="0" tIns="0" rIns="0" bIns="0" rtlCol="0" anchor="ctr"/>
+          <a:lstStyle/>
+          <a:p>
+            <a:pPr indent="0" marL="0">
+              <a:buNone/>
+            </a:pPr>
+            <a:r>
+              <a:rPr lang="en-US" sz="1200" b="1" dirty="0">
+                <a:solidFill>
+                  <a:srgbClr val="595959"/>
+                </a:solidFill>
+                <a:latin typeface="Arial" pitchFamily="34" charset="0"/>
+                <a:ea typeface="Arial" pitchFamily="34" charset="-122"/>
+                <a:cs typeface="Arial" pitchFamily="34" charset="-120"/>
+              </a:rPr>
+              <a:t>03</a:t>
+            </a:r>
+            <a:endParaRPr lang="en-US" sz="1200" dirty="0"/>
+          </a:p>
+        </p:txBody>
+      </p:sp>
+      <p:sp>
+        <p:nvSpPr>
+          <p:cNvPr id="11" name="Text 8"/>
+          <p:cNvSpPr txBox="1"/>
+          <p:nvPr/>
+        </p:nvSpPr>
+        <p:spPr>
+          <a:xfrm>
+            <a:off x="1005840" y="3941064"/>
+            <a:ext cx="2743200" cy="256032"/>
+          </a:xfrm>
+          <a:prstGeom prst="rect">
+            <a:avLst/>
+          </a:prstGeom>
+          <a:noFill/>
+          <a:ln/>
+        </p:spPr>
+        <p:txBody>
+          <a:bodyPr wrap="square" lIns="0" tIns="0" rIns="0" bIns="0" rtlCol="0" anchor="ctr"/>
+          <a:lstStyle/>
+          <a:p>
+            <a:pPr indent="0" marL="0">
+              <a:buNone/>
+            </a:pPr>
+            <a:r>
+              <a:rPr lang="en-US" sz="1200" dirty="0">
+                <a:solidFill>
+                  <a:srgbClr val="595959"/>
+                </a:solidFill>
+                <a:latin typeface="Arial" pitchFamily="34" charset="0"/>
+                <a:ea typeface="Arial" pitchFamily="34" charset="-122"/>
+                <a:cs typeface="Arial" pitchFamily="34" charset="-120"/>
+              </a:rPr>
+              <a:t>Ideate</a:t>
+            </a:r>
+            <a:endParaRPr lang="en-US" sz="1200" dirty="0"/>
+          </a:p>
+        </p:txBody>
+      </p:sp>
+      <p:sp>
+        <p:nvSpPr>
+          <p:cNvPr id="12" name="Text 9"/>
+          <p:cNvSpPr txBox="1"/>
+          <p:nvPr/>
+        </p:nvSpPr>
+        <p:spPr>
+          <a:xfrm>
+            <a:off x="548640" y="4197096"/>
+            <a:ext cx="457200" cy="256032"/>
+          </a:xfrm>
+          <a:prstGeom prst="rect">
+            <a:avLst/>
+          </a:prstGeom>
+          <a:noFill/>
+          <a:ln/>
+        </p:spPr>
+        <p:txBody>
+          <a:bodyPr wrap="square" lIns="0" tIns="0" rIns="0" bIns="0" rtlCol="0" anchor="ctr"/>
+          <a:lstStyle/>
+          <a:p>
+            <a:pPr indent="0" marL="0">
+              <a:buNone/>
+            </a:pPr>
+            <a:r>
+              <a:rPr lang="en-US" sz="1200" b="1" dirty="0">
+                <a:solidFill>
+                  <a:srgbClr val="595959"/>
+                </a:solidFill>
+                <a:latin typeface="Arial" pitchFamily="34" charset="0"/>
+                <a:ea typeface="Arial" pitchFamily="34" charset="-122"/>
+                <a:cs typeface="Arial" pitchFamily="34" charset="-120"/>
+              </a:rPr>
+              <a:t>04</a:t>
+            </a:r>
+            <a:endParaRPr lang="en-US" sz="1200" dirty="0"/>
+          </a:p>
+        </p:txBody>
+      </p:sp>
+      <p:sp>
+        <p:nvSpPr>
+          <p:cNvPr id="13" name="Text 10"/>
+          <p:cNvSpPr txBox="1"/>
+          <p:nvPr/>
+        </p:nvSpPr>
+        <p:spPr>
+          <a:xfrm>
+            <a:off x="1005840" y="4197096"/>
+            <a:ext cx="2743200" cy="256032"/>
+          </a:xfrm>
+          <a:prstGeom prst="rect">
+            <a:avLst/>
+          </a:prstGeom>
+          <a:noFill/>
+          <a:ln/>
+        </p:spPr>
+        <p:txBody>
+          <a:bodyPr wrap="square" lIns="0" tIns="0" rIns="0" bIns="0" rtlCol="0" anchor="ctr"/>
+          <a:lstStyle/>
+          <a:p>
+            <a:pPr indent="0" marL="0">
+              <a:buNone/>
+            </a:pPr>
+            <a:r>
+              <a:rPr lang="en-US" sz="1200" dirty="0">
+                <a:solidFill>
+                  <a:srgbClr val="595959"/>
+                </a:solidFill>
+                <a:latin typeface="Arial" pitchFamily="34" charset="0"/>
+                <a:ea typeface="Arial" pitchFamily="34" charset="-122"/>
+                <a:cs typeface="Arial" pitchFamily="34" charset="-120"/>
+              </a:rPr>
+              <a:t>Prototype</a:t>
+            </a:r>
+            <a:endParaRPr lang="en-US" sz="1200" dirty="0"/>
+          </a:p>
+        </p:txBody>
+      </p:sp>
+      <p:sp>
+        <p:nvSpPr>
+          <p:cNvPr id="14" name="Text 11"/>
+          <p:cNvSpPr txBox="1"/>
+          <p:nvPr/>
+        </p:nvSpPr>
+        <p:spPr>
+          <a:xfrm>
+            <a:off x="548640" y="4453128"/>
+            <a:ext cx="457200" cy="256032"/>
+          </a:xfrm>
+          <a:prstGeom prst="rect">
+            <a:avLst/>
+          </a:prstGeom>
+          <a:noFill/>
+          <a:ln/>
+        </p:spPr>
+        <p:txBody>
+          <a:bodyPr wrap="square" lIns="0" tIns="0" rIns="0" bIns="0" rtlCol="0" anchor="ctr"/>
+          <a:lstStyle/>
+          <a:p>
+            <a:pPr indent="0" marL="0">
+              <a:buNone/>
+            </a:pPr>
+            <a:r>
+              <a:rPr lang="en-US" sz="1200" b="1" dirty="0">
+                <a:solidFill>
+                  <a:srgbClr val="FFFFFF"/>
+                </a:solidFill>
+                <a:latin typeface="Arial" pitchFamily="34" charset="0"/>
+                <a:ea typeface="Arial" pitchFamily="34" charset="-122"/>
+                <a:cs typeface="Arial" pitchFamily="34" charset="-120"/>
+              </a:rPr>
+              <a:t>05</a:t>
+            </a:r>
+            <a:endParaRPr lang="en-US" sz="1200" dirty="0"/>
+          </a:p>
+        </p:txBody>
+      </p:sp>
+      <p:sp>
+        <p:nvSpPr>
+          <p:cNvPr id="15" name="Text 12"/>
+          <p:cNvSpPr txBox="1"/>
+          <p:nvPr/>
+        </p:nvSpPr>
+        <p:spPr>
+          <a:xfrm>
+            <a:off x="1005840" y="4453128"/>
+            <a:ext cx="2743200" cy="256032"/>
+          </a:xfrm>
+          <a:prstGeom prst="rect">
+            <a:avLst/>
+          </a:prstGeom>
+          <a:noFill/>
+          <a:ln/>
+        </p:spPr>
+        <p:txBody>
+          <a:bodyPr wrap="square" lIns="0" tIns="0" rIns="0" bIns="0" rtlCol="0" anchor="ctr"/>
+          <a:lstStyle/>
+          <a:p>
+            <a:pPr indent="0" marL="0">
+              <a:buNone/>
+            </a:pPr>
+            <a:r>
+              <a:rPr lang="en-US" sz="1200" b="1" dirty="0">
+                <a:solidFill>
+                  <a:srgbClr val="FFFFFF"/>
+                </a:solidFill>
+                <a:latin typeface="Arial" pitchFamily="34" charset="0"/>
+                <a:ea typeface="Arial" pitchFamily="34" charset="-122"/>
+                <a:cs typeface="Arial" pitchFamily="34" charset="-120"/>
+              </a:rPr>
+              <a:t>Test</a:t>
+            </a:r>
+            <a:endParaRPr lang="en-US" sz="1200" dirty="0"/>
+          </a:p>
+        </p:txBody>
+      </p:sp>
+      <p:sp>
+        <p:nvSpPr>
+          <p:cNvPr id="16" name="Shape 13"/>
           <p:cNvSpPr/>
           <p:nvPr/>
         </p:nvSpPr>
@@ -7639,7 +8848,7 @@
       </p:sp>
       <p:sp>
         <p:nvSpPr>
-          <p:cNvPr id="7" name="Text 4"/>
+          <p:cNvPr id="17" name="Text 14"/>
           <p:cNvSpPr txBox="1"/>
           <p:nvPr/>
         </p:nvSpPr>
@@ -7678,14 +8887,14 @@
       </p:sp>
       <p:sp>
         <p:nvSpPr>
-          <p:cNvPr id="8" name="Text 5"/>
-          <p:cNvSpPr txBox="1"/>
-          <p:nvPr/>
-        </p:nvSpPr>
-        <p:spPr>
-          <a:xfrm>
-            <a:off x="4754880" y="960120"/>
-            <a:ext cx="3657600" cy="960120"/>
+          <p:cNvPr id="18" name="Text 15"/>
+          <p:cNvSpPr txBox="1"/>
+          <p:nvPr/>
+        </p:nvSpPr>
+        <p:spPr>
+          <a:xfrm>
+            <a:off x="4754880" y="978408"/>
+            <a:ext cx="3657600" cy="1005840"/>
           </a:xfrm>
           <a:prstGeom prst="rect">
             <a:avLst/>
@@ -7701,7 +8910,7 @@
               <a:buNone/>
             </a:pPr>
             <a:r>
-              <a:rPr lang="en-US" sz="1400" dirty="0">
+              <a:rPr lang="en-US" sz="1500" dirty="0">
                 <a:solidFill>
                   <a:srgbClr val="000000"/>
                 </a:solidFill>
@@ -7711,13 +8920,13 @@
               </a:rPr>
               <a:t>Try the prototype in the real world and measure what happens. Learn what works and what does not.</a:t>
             </a:r>
-            <a:endParaRPr lang="en-US" sz="1400" dirty="0"/>
-          </a:p>
-        </p:txBody>
-      </p:sp>
-      <p:sp>
-        <p:nvSpPr>
-          <p:cNvPr id="9" name="Text 6"/>
+            <a:endParaRPr lang="en-US" sz="1500" dirty="0"/>
+          </a:p>
+        </p:txBody>
+      </p:sp>
+      <p:sp>
+        <p:nvSpPr>
+          <p:cNvPr id="19" name="Text 16"/>
           <p:cNvSpPr txBox="1"/>
           <p:nvPr/>
         </p:nvSpPr>
@@ -7756,14 +8965,14 @@
       </p:sp>
       <p:sp>
         <p:nvSpPr>
-          <p:cNvPr id="10" name="Text 7"/>
-          <p:cNvSpPr txBox="1"/>
-          <p:nvPr/>
-        </p:nvSpPr>
-        <p:spPr>
-          <a:xfrm>
-            <a:off x="4754880" y="2331720"/>
-            <a:ext cx="3657600" cy="960120"/>
+          <p:cNvPr id="20" name="Text 17"/>
+          <p:cNvSpPr txBox="1"/>
+          <p:nvPr/>
+        </p:nvSpPr>
+        <p:spPr>
+          <a:xfrm>
+            <a:off x="4754880" y="2350008"/>
+            <a:ext cx="3657600" cy="1005840"/>
           </a:xfrm>
           <a:prstGeom prst="rect">
             <a:avLst/>
@@ -7779,7 +8988,7 @@
               <a:buNone/>
             </a:pPr>
             <a:r>
-              <a:rPr lang="en-US" sz="1400" dirty="0">
+              <a:rPr lang="en-US" sz="1500" dirty="0">
                 <a:solidFill>
                   <a:srgbClr val="000000"/>
                 </a:solidFill>
@@ -7789,13 +8998,13 @@
               </a:rPr>
               <a:t>Does it actually solve the problem?</a:t>
             </a:r>
-            <a:endParaRPr lang="en-US" sz="1400" dirty="0"/>
-          </a:p>
-        </p:txBody>
-      </p:sp>
-      <p:sp>
-        <p:nvSpPr>
-          <p:cNvPr id="11" name="Text 8"/>
+            <a:endParaRPr lang="en-US" sz="1500" dirty="0"/>
+          </a:p>
+        </p:txBody>
+      </p:sp>
+      <p:sp>
+        <p:nvSpPr>
+          <p:cNvPr id="21" name="Text 18"/>
           <p:cNvSpPr txBox="1"/>
           <p:nvPr/>
         </p:nvSpPr>
@@ -7834,14 +9043,14 @@
       </p:sp>
       <p:sp>
         <p:nvSpPr>
-          <p:cNvPr id="12" name="Text 9"/>
-          <p:cNvSpPr txBox="1"/>
-          <p:nvPr/>
-        </p:nvSpPr>
-        <p:spPr>
-          <a:xfrm>
-            <a:off x="4754880" y="3703320"/>
-            <a:ext cx="3657600" cy="960120"/>
+          <p:cNvPr id="22" name="Text 19"/>
+          <p:cNvSpPr txBox="1"/>
+          <p:nvPr/>
+        </p:nvSpPr>
+        <p:spPr>
+          <a:xfrm>
+            <a:off x="4754880" y="3721608"/>
+            <a:ext cx="3657600" cy="1005840"/>
           </a:xfrm>
           <a:prstGeom prst="rect">
             <a:avLst/>
@@ -7857,7 +9066,7 @@
               <a:buNone/>
             </a:pPr>
             <a:r>
-              <a:rPr lang="en-US" sz="1400" dirty="0">
+              <a:rPr lang="en-US" sz="1500" dirty="0">
                 <a:solidFill>
                   <a:srgbClr val="000000"/>
                 </a:solidFill>
@@ -7867,7 +9076,7 @@
               </a:rPr>
               <a:t>compared Ramer against Ollama's default on a real 8 GB RTX 5060, and checked results with git diff and pytest.</a:t>
             </a:r>
-            <a:endParaRPr lang="en-US" sz="1400" dirty="0"/>
+            <a:endParaRPr lang="en-US" sz="1500" dirty="0"/>
           </a:p>
         </p:txBody>
       </p:sp>
@@ -8068,7 +9277,7 @@
         <p:spPr>
           <a:xfrm>
             <a:off x="457200" y="1188720"/>
-            <a:ext cx="1938528" cy="2834640"/>
+            <a:ext cx="1938528" cy="2514600"/>
           </a:xfrm>
           <a:prstGeom prst="rect">
             <a:avLst/>
@@ -8170,8 +9379,8 @@
         </p:nvSpPr>
         <p:spPr>
           <a:xfrm>
-            <a:off x="640080" y="2834640"/>
-            <a:ext cx="1600200" cy="1097280"/>
+            <a:off x="640080" y="2743200"/>
+            <a:ext cx="1600200" cy="914400"/>
           </a:xfrm>
           <a:prstGeom prst="rect">
             <a:avLst/>
@@ -8210,7 +9419,7 @@
         <p:spPr>
           <a:xfrm>
             <a:off x="2542032" y="1188720"/>
-            <a:ext cx="1938528" cy="2834640"/>
+            <a:ext cx="1938528" cy="2514600"/>
           </a:xfrm>
           <a:prstGeom prst="rect">
             <a:avLst/>
@@ -8312,8 +9521,8 @@
         </p:nvSpPr>
         <p:spPr>
           <a:xfrm>
-            <a:off x="2724912" y="2834640"/>
-            <a:ext cx="1600200" cy="1097280"/>
+            <a:off x="2724912" y="2743200"/>
+            <a:ext cx="1600200" cy="914400"/>
           </a:xfrm>
           <a:prstGeom prst="rect">
             <a:avLst/>
@@ -8352,7 +9561,7 @@
         <p:spPr>
           <a:xfrm>
             <a:off x="4626864" y="1188720"/>
-            <a:ext cx="1938528" cy="2834640"/>
+            <a:ext cx="1938528" cy="2514600"/>
           </a:xfrm>
           <a:prstGeom prst="rect">
             <a:avLst/>
@@ -8454,8 +9663,8 @@
         </p:nvSpPr>
         <p:spPr>
           <a:xfrm>
-            <a:off x="4809744" y="2834640"/>
-            <a:ext cx="1600200" cy="1097280"/>
+            <a:off x="4809744" y="2743200"/>
+            <a:ext cx="1600200" cy="914400"/>
           </a:xfrm>
           <a:prstGeom prst="rect">
             <a:avLst/>
@@ -8494,7 +9703,7 @@
         <p:spPr>
           <a:xfrm>
             <a:off x="6711696" y="1188720"/>
-            <a:ext cx="1938528" cy="2834640"/>
+            <a:ext cx="1938528" cy="2514600"/>
           </a:xfrm>
           <a:prstGeom prst="rect">
             <a:avLst/>
@@ -8596,8 +9805,8 @@
         </p:nvSpPr>
         <p:spPr>
           <a:xfrm>
-            <a:off x="6894576" y="2834640"/>
-            <a:ext cx="1600200" cy="1097280"/>
+            <a:off x="6894576" y="2743200"/>
+            <a:ext cx="1600200" cy="914400"/>
           </a:xfrm>
           <a:prstGeom prst="rect">
             <a:avLst/>
@@ -8629,32 +9838,57 @@
       </p:sp>
       <p:sp>
         <p:nvSpPr>
-          <p:cNvPr id="23" name="Text 20"/>
-          <p:cNvSpPr txBox="1"/>
-          <p:nvPr/>
-        </p:nvSpPr>
-        <p:spPr>
-          <a:xfrm>
-            <a:off x="457200" y="4206240"/>
-            <a:ext cx="8229600" cy="365760"/>
-          </a:xfrm>
-          <a:prstGeom prst="rect">
-            <a:avLst/>
-          </a:prstGeom>
-          <a:noFill/>
-          <a:ln/>
-        </p:spPr>
-        <p:txBody>
-          <a:bodyPr wrap="square" lIns="0" tIns="0" rIns="0" bIns="0" rtlCol="0" anchor="ctr"/>
-          <a:lstStyle/>
-          <a:p>
-            <a:pPr indent="0" marL="0">
-              <a:buNone/>
-            </a:pPr>
-            <a:r>
-              <a:rPr lang="en-US" sz="1300" i="1" dirty="0">
-                <a:solidFill>
-                  <a:srgbClr val="595959"/>
+          <p:cNvPr id="23" name="Shape 20"/>
+          <p:cNvSpPr/>
+          <p:nvPr/>
+        </p:nvSpPr>
+        <p:spPr>
+          <a:xfrm>
+            <a:off x="457200" y="3886200"/>
+            <a:ext cx="8229600" cy="685800"/>
+          </a:xfrm>
+          <a:prstGeom prst="rect">
+            <a:avLst/>
+          </a:prstGeom>
+          <a:solidFill>
+            <a:srgbClr val="F2F2F2"/>
+          </a:solidFill>
+          <a:ln w="12700">
+            <a:solidFill>
+              <a:srgbClr val="F2F2F2"/>
+            </a:solidFill>
+            <a:prstDash val="solid"/>
+          </a:ln>
+        </p:spPr>
+      </p:sp>
+      <p:sp>
+        <p:nvSpPr>
+          <p:cNvPr id="24" name="Text 21"/>
+          <p:cNvSpPr txBox="1"/>
+          <p:nvPr/>
+        </p:nvSpPr>
+        <p:spPr>
+          <a:xfrm>
+            <a:off x="731520" y="3886200"/>
+            <a:ext cx="7680960" cy="685800"/>
+          </a:xfrm>
+          <a:prstGeom prst="rect">
+            <a:avLst/>
+          </a:prstGeom>
+          <a:noFill/>
+          <a:ln/>
+        </p:spPr>
+        <p:txBody>
+          <a:bodyPr wrap="square" lIns="0" tIns="0" rIns="0" bIns="0" rtlCol="0" anchor="ctr"/>
+          <a:lstStyle/>
+          <a:p>
+            <a:pPr indent="0" marL="0">
+              <a:buNone/>
+            </a:pPr>
+            <a:r>
+              <a:rPr lang="en-US" sz="1400" dirty="0">
+                <a:solidFill>
+                  <a:srgbClr val="000000"/>
                 </a:solidFill>
                 <a:latin typeface="Arial" pitchFamily="34" charset="0"/>
                 <a:ea typeface="Arial" pitchFamily="34" charset="-122"/>
@@ -8662,7 +9896,7 @@
               </a:rPr>
               <a:t>Not a benchmark suite and not a general guarantee: real measurements on one real machine.</a:t>
             </a:r>
-            <a:endParaRPr lang="en-US" sz="1300" dirty="0"/>
+            <a:endParaRPr lang="en-US" sz="1400" dirty="0"/>
           </a:p>
         </p:txBody>
       </p:sp>
@@ -8863,7 +10097,7 @@
         <p:spPr>
           <a:xfrm>
             <a:off x="457200" y="1188720"/>
-            <a:ext cx="2606040" cy="3291840"/>
+            <a:ext cx="2606040" cy="2697480"/>
           </a:xfrm>
           <a:prstGeom prst="rect">
             <a:avLst/>
@@ -8887,7 +10121,7 @@
         </p:nvSpPr>
         <p:spPr>
           <a:xfrm>
-            <a:off x="685800" y="1463040"/>
+            <a:off x="685800" y="1371600"/>
             <a:ext cx="2194560" cy="1005840"/>
           </a:xfrm>
           <a:prstGeom prst="rect">
@@ -8926,7 +10160,7 @@
         </p:nvSpPr>
         <p:spPr>
           <a:xfrm>
-            <a:off x="685800" y="2606040"/>
+            <a:off x="685800" y="2423160"/>
             <a:ext cx="2194560" cy="640080"/>
           </a:xfrm>
           <a:prstGeom prst="rect">
@@ -8965,8 +10199,8 @@
         </p:nvSpPr>
         <p:spPr>
           <a:xfrm>
-            <a:off x="685800" y="3383280"/>
-            <a:ext cx="2194560" cy="822960"/>
+            <a:off x="685800" y="3108960"/>
+            <a:ext cx="2194560" cy="640080"/>
           </a:xfrm>
           <a:prstGeom prst="rect">
             <a:avLst/>
@@ -9005,7 +10239,7 @@
         <p:spPr>
           <a:xfrm>
             <a:off x="3246120" y="1188720"/>
-            <a:ext cx="2606040" cy="3291840"/>
+            <a:ext cx="2606040" cy="2697480"/>
           </a:xfrm>
           <a:prstGeom prst="rect">
             <a:avLst/>
@@ -9029,7 +10263,7 @@
         </p:nvSpPr>
         <p:spPr>
           <a:xfrm>
-            <a:off x="3474720" y="1463040"/>
+            <a:off x="3474720" y="1371600"/>
             <a:ext cx="2194560" cy="1005840"/>
           </a:xfrm>
           <a:prstGeom prst="rect">
@@ -9068,7 +10302,7 @@
         </p:nvSpPr>
         <p:spPr>
           <a:xfrm>
-            <a:off x="3474720" y="2606040"/>
+            <a:off x="3474720" y="2423160"/>
             <a:ext cx="2194560" cy="640080"/>
           </a:xfrm>
           <a:prstGeom prst="rect">
@@ -9107,8 +10341,8 @@
         </p:nvSpPr>
         <p:spPr>
           <a:xfrm>
-            <a:off x="3474720" y="3383280"/>
-            <a:ext cx="2194560" cy="822960"/>
+            <a:off x="3474720" y="3108960"/>
+            <a:ext cx="2194560" cy="640080"/>
           </a:xfrm>
           <a:prstGeom prst="rect">
             <a:avLst/>
@@ -9147,7 +10381,7 @@
         <p:spPr>
           <a:xfrm>
             <a:off x="6035040" y="1188720"/>
-            <a:ext cx="2606040" cy="3291840"/>
+            <a:ext cx="2606040" cy="2697480"/>
           </a:xfrm>
           <a:prstGeom prst="rect">
             <a:avLst/>
@@ -9171,7 +10405,7 @@
         </p:nvSpPr>
         <p:spPr>
           <a:xfrm>
-            <a:off x="6263640" y="1463040"/>
+            <a:off x="6263640" y="1371600"/>
             <a:ext cx="2194560" cy="1005840"/>
           </a:xfrm>
           <a:prstGeom prst="rect">
@@ -9210,7 +10444,7 @@
         </p:nvSpPr>
         <p:spPr>
           <a:xfrm>
-            <a:off x="6263640" y="2606040"/>
+            <a:off x="6263640" y="2423160"/>
             <a:ext cx="2194560" cy="640080"/>
           </a:xfrm>
           <a:prstGeom prst="rect">
@@ -9249,8 +10483,8 @@
         </p:nvSpPr>
         <p:spPr>
           <a:xfrm>
-            <a:off x="6263640" y="3383280"/>
-            <a:ext cx="2194560" cy="822960"/>
+            <a:off x="6263640" y="3108960"/>
+            <a:ext cx="2194560" cy="640080"/>
           </a:xfrm>
           <a:prstGeom prst="rect">
             <a:avLst/>
@@ -9277,6 +10511,70 @@
               <a:t>89.2 s → 55.4 s, same correct result</a:t>
             </a:r>
             <a:endParaRPr lang="en-US" sz="1300" dirty="0"/>
+          </a:p>
+        </p:txBody>
+      </p:sp>
+      <p:sp>
+        <p:nvSpPr>
+          <p:cNvPr id="19" name="Shape 16"/>
+          <p:cNvSpPr/>
+          <p:nvPr/>
+        </p:nvSpPr>
+        <p:spPr>
+          <a:xfrm>
+            <a:off x="457200" y="4023360"/>
+            <a:ext cx="8229600" cy="548640"/>
+          </a:xfrm>
+          <a:prstGeom prst="rect">
+            <a:avLst/>
+          </a:prstGeom>
+          <a:solidFill>
+            <a:srgbClr val="F2F2F2"/>
+          </a:solidFill>
+          <a:ln w="12700">
+            <a:solidFill>
+              <a:srgbClr val="F2F2F2"/>
+            </a:solidFill>
+            <a:prstDash val="solid"/>
+          </a:ln>
+        </p:spPr>
+      </p:sp>
+      <p:sp>
+        <p:nvSpPr>
+          <p:cNvPr id="20" name="Text 17"/>
+          <p:cNvSpPr txBox="1"/>
+          <p:nvPr/>
+        </p:nvSpPr>
+        <p:spPr>
+          <a:xfrm>
+            <a:off x="731520" y="4023360"/>
+            <a:ext cx="7680960" cy="548640"/>
+          </a:xfrm>
+          <a:prstGeom prst="rect">
+            <a:avLst/>
+          </a:prstGeom>
+          <a:noFill/>
+          <a:ln/>
+        </p:spPr>
+        <p:txBody>
+          <a:bodyPr wrap="square" lIns="0" tIns="0" rIns="0" bIns="0" rtlCol="0" anchor="ctr"/>
+          <a:lstStyle/>
+          <a:p>
+            <a:pPr indent="0" marL="0">
+              <a:buNone/>
+            </a:pPr>
+            <a:r>
+              <a:rPr lang="en-US" sz="1400" dirty="0">
+                <a:solidFill>
+                  <a:srgbClr val="000000"/>
+                </a:solidFill>
+                <a:latin typeface="Arial" pitchFamily="34" charset="0"/>
+                <a:ea typeface="Arial" pitchFamily="34" charset="-122"/>
+                <a:cs typeface="Arial" pitchFamily="34" charset="-120"/>
+              </a:rPr>
+              <a:t>All compared with Ollama's default placement, on the same machine, with the result checked.</a:t>
+            </a:r>
+            <a:endParaRPr lang="en-US" sz="1400" dirty="0"/>
           </a:p>
         </p:txBody>
       </p:sp>
@@ -9492,7 +10790,7 @@
         </p:nvSpPr>
         <p:spPr>
           <a:xfrm>
-            <a:off x="5852160" y="1280160"/>
+            <a:off x="5852160" y="1188720"/>
             <a:ext cx="2834640" cy="822960"/>
           </a:xfrm>
           <a:prstGeom prst="rect">
@@ -9531,8 +10829,8 @@
         </p:nvSpPr>
         <p:spPr>
           <a:xfrm>
-            <a:off x="5852160" y="2103120"/>
-            <a:ext cx="2834640" cy="594360"/>
+            <a:off x="5852160" y="2011680"/>
+            <a:ext cx="2834640" cy="548640"/>
           </a:xfrm>
           <a:prstGeom prst="rect">
             <a:avLst/>
@@ -9570,8 +10868,47 @@
         </p:nvSpPr>
         <p:spPr>
           <a:xfrm>
-            <a:off x="5852160" y="2834640"/>
-            <a:ext cx="2834640" cy="1371600"/>
+            <a:off x="5852160" y="2743200"/>
+            <a:ext cx="2834640" cy="640080"/>
+          </a:xfrm>
+          <a:prstGeom prst="rect">
+            <a:avLst/>
+          </a:prstGeom>
+          <a:noFill/>
+          <a:ln/>
+        </p:spPr>
+        <p:txBody>
+          <a:bodyPr wrap="square" lIns="0" tIns="0" rIns="0" bIns="0" rtlCol="0" anchor="ctr"/>
+          <a:lstStyle/>
+          <a:p>
+            <a:pPr indent="0" marL="0">
+              <a:buNone/>
+            </a:pPr>
+            <a:r>
+              <a:rPr lang="en-US" sz="3600" b="1" dirty="0">
+                <a:solidFill>
+                  <a:srgbClr val="000000"/>
+                </a:solidFill>
+                <a:latin typeface="Arial" pitchFamily="34" charset="0"/>
+                <a:ea typeface="Arial" pitchFamily="34" charset="-122"/>
+                <a:cs typeface="Arial" pitchFamily="34" charset="-120"/>
+              </a:rPr>
+              <a:t>6.6 → 3.6</a:t>
+            </a:r>
+            <a:endParaRPr lang="en-US" sz="3600" dirty="0"/>
+          </a:p>
+        </p:txBody>
+      </p:sp>
+      <p:sp>
+        <p:nvSpPr>
+          <p:cNvPr id="11" name="Text 7"/>
+          <p:cNvSpPr txBox="1"/>
+          <p:nvPr/>
+        </p:nvSpPr>
+        <p:spPr>
+          <a:xfrm>
+            <a:off x="5852160" y="3429000"/>
+            <a:ext cx="2834640" cy="1005840"/>
           </a:xfrm>
           <a:prstGeom prst="rect">
             <a:avLst/>
@@ -9595,7 +10932,7 @@
                 <a:ea typeface="Arial" pitchFamily="34" charset="-122"/>
                 <a:cs typeface="Arial" pitchFamily="34" charset="-120"/>
               </a:rPr>
-              <a:t>Keeping the busy model loaded (“sticky”) is what stops the thrashing: model swaps fell from 6.6 to 3.6 per run.</a:t>
+              <a:t>model swaps per run. Keeping the busy model loaded (“sticky”) is what stops the thrashing.</a:t>
             </a:r>
             <a:endParaRPr lang="en-US" sz="1300" dirty="0"/>
           </a:p>
@@ -10824,7 +12161,7 @@
         <p:spPr>
           <a:xfrm>
             <a:off x="457200" y="1188720"/>
-            <a:ext cx="4023360" cy="3291840"/>
+            <a:ext cx="4023360" cy="2788920"/>
           </a:xfrm>
           <a:prstGeom prst="rect">
             <a:avLst/>
@@ -10973,7 +12310,7 @@
         <p:spPr>
           <a:xfrm>
             <a:off x="4663440" y="1188720"/>
-            <a:ext cx="4023360" cy="3291840"/>
+            <a:ext cx="4023360" cy="2788920"/>
           </a:xfrm>
           <a:prstGeom prst="rect">
             <a:avLst/>
@@ -11108,6 +12445,70 @@
                 <a:cs typeface="Arial" pitchFamily="34" charset="-120"/>
               </a:rPr>
               <a:t>Apple Silicon Macs: no separate VRAM to optimize</a:t>
+            </a:r>
+            <a:endParaRPr lang="en-US" sz="1400" dirty="0"/>
+          </a:p>
+        </p:txBody>
+      </p:sp>
+      <p:sp>
+        <p:nvSpPr>
+          <p:cNvPr id="13" name="Shape 10"/>
+          <p:cNvSpPr/>
+          <p:nvPr/>
+        </p:nvSpPr>
+        <p:spPr>
+          <a:xfrm>
+            <a:off x="457200" y="4114800"/>
+            <a:ext cx="8229600" cy="457200"/>
+          </a:xfrm>
+          <a:prstGeom prst="rect">
+            <a:avLst/>
+          </a:prstGeom>
+          <a:solidFill>
+            <a:srgbClr val="000000"/>
+          </a:solidFill>
+          <a:ln w="12700">
+            <a:solidFill>
+              <a:srgbClr val="000000"/>
+            </a:solidFill>
+            <a:prstDash val="solid"/>
+          </a:ln>
+        </p:spPr>
+      </p:sp>
+      <p:sp>
+        <p:nvSpPr>
+          <p:cNvPr id="14" name="Text 11"/>
+          <p:cNvSpPr txBox="1"/>
+          <p:nvPr/>
+        </p:nvSpPr>
+        <p:spPr>
+          <a:xfrm>
+            <a:off x="731520" y="4114800"/>
+            <a:ext cx="7680960" cy="457200"/>
+          </a:xfrm>
+          <a:prstGeom prst="rect">
+            <a:avLst/>
+          </a:prstGeom>
+          <a:noFill/>
+          <a:ln/>
+        </p:spPr>
+        <p:txBody>
+          <a:bodyPr wrap="square" lIns="0" tIns="0" rIns="0" bIns="0" rtlCol="0" anchor="ctr"/>
+          <a:lstStyle/>
+          <a:p>
+            <a:pPr indent="0" marL="0">
+              <a:buNone/>
+            </a:pPr>
+            <a:r>
+              <a:rPr lang="en-US" sz="1400" b="1" dirty="0">
+                <a:solidFill>
+                  <a:srgbClr val="FFFFFF"/>
+                </a:solidFill>
+                <a:latin typeface="Arial" pitchFamily="34" charset="0"/>
+                <a:ea typeface="Arial" pitchFamily="34" charset="-122"/>
+                <a:cs typeface="Arial" pitchFamily="34" charset="-120"/>
+              </a:rPr>
+              <a:t>The honest thesis: the benefit grows with how much of the work is local decoding.</a:t>
             </a:r>
             <a:endParaRPr lang="en-US" sz="1400" dirty="0"/>
           </a:p>
@@ -12979,8 +14380,8 @@
         </p:nvSpPr>
         <p:spPr>
           <a:xfrm>
-            <a:off x="548640" y="2697480"/>
-            <a:ext cx="3474720" cy="914400"/>
+            <a:off x="548640" y="2560320"/>
+            <a:ext cx="3474720" cy="640080"/>
           </a:xfrm>
           <a:prstGeom prst="rect">
             <a:avLst/>
@@ -12996,7 +14397,7 @@
               <a:buNone/>
             </a:pPr>
             <a:r>
-              <a:rPr lang="en-US" sz="1800" i="1" dirty="0">
+              <a:rPr lang="en-US" sz="1600" i="1" dirty="0">
                 <a:solidFill>
                   <a:srgbClr val="BFBFBF"/>
                 </a:solidFill>
@@ -13006,13 +14407,403 @@
               </a:rPr>
               <a:t>Start with people, not technology.</a:t>
             </a:r>
-            <a:endParaRPr lang="en-US" sz="1800" dirty="0"/>
-          </a:p>
-        </p:txBody>
-      </p:sp>
-      <p:sp>
-        <p:nvSpPr>
-          <p:cNvPr id="6" name="Shape 3"/>
+            <a:endParaRPr lang="en-US" sz="1600" dirty="0"/>
+          </a:p>
+        </p:txBody>
+      </p:sp>
+      <p:sp>
+        <p:nvSpPr>
+          <p:cNvPr id="6" name="Text 3"/>
+          <p:cNvSpPr txBox="1"/>
+          <p:nvPr/>
+        </p:nvSpPr>
+        <p:spPr>
+          <a:xfrm>
+            <a:off x="548640" y="3429000"/>
+            <a:ext cx="457200" cy="256032"/>
+          </a:xfrm>
+          <a:prstGeom prst="rect">
+            <a:avLst/>
+          </a:prstGeom>
+          <a:noFill/>
+          <a:ln/>
+        </p:spPr>
+        <p:txBody>
+          <a:bodyPr wrap="square" lIns="0" tIns="0" rIns="0" bIns="0" rtlCol="0" anchor="ctr"/>
+          <a:lstStyle/>
+          <a:p>
+            <a:pPr indent="0" marL="0">
+              <a:buNone/>
+            </a:pPr>
+            <a:r>
+              <a:rPr lang="en-US" sz="1200" b="1" dirty="0">
+                <a:solidFill>
+                  <a:srgbClr val="FFFFFF"/>
+                </a:solidFill>
+                <a:latin typeface="Arial" pitchFamily="34" charset="0"/>
+                <a:ea typeface="Arial" pitchFamily="34" charset="-122"/>
+                <a:cs typeface="Arial" pitchFamily="34" charset="-120"/>
+              </a:rPr>
+              <a:t>01</a:t>
+            </a:r>
+            <a:endParaRPr lang="en-US" sz="1200" dirty="0"/>
+          </a:p>
+        </p:txBody>
+      </p:sp>
+      <p:sp>
+        <p:nvSpPr>
+          <p:cNvPr id="7" name="Text 4"/>
+          <p:cNvSpPr txBox="1"/>
+          <p:nvPr/>
+        </p:nvSpPr>
+        <p:spPr>
+          <a:xfrm>
+            <a:off x="1005840" y="3429000"/>
+            <a:ext cx="2743200" cy="256032"/>
+          </a:xfrm>
+          <a:prstGeom prst="rect">
+            <a:avLst/>
+          </a:prstGeom>
+          <a:noFill/>
+          <a:ln/>
+        </p:spPr>
+        <p:txBody>
+          <a:bodyPr wrap="square" lIns="0" tIns="0" rIns="0" bIns="0" rtlCol="0" anchor="ctr"/>
+          <a:lstStyle/>
+          <a:p>
+            <a:pPr indent="0" marL="0">
+              <a:buNone/>
+            </a:pPr>
+            <a:r>
+              <a:rPr lang="en-US" sz="1200" b="1" dirty="0">
+                <a:solidFill>
+                  <a:srgbClr val="FFFFFF"/>
+                </a:solidFill>
+                <a:latin typeface="Arial" pitchFamily="34" charset="0"/>
+                <a:ea typeface="Arial" pitchFamily="34" charset="-122"/>
+                <a:cs typeface="Arial" pitchFamily="34" charset="-120"/>
+              </a:rPr>
+              <a:t>Empathize</a:t>
+            </a:r>
+            <a:endParaRPr lang="en-US" sz="1200" dirty="0"/>
+          </a:p>
+        </p:txBody>
+      </p:sp>
+      <p:sp>
+        <p:nvSpPr>
+          <p:cNvPr id="8" name="Text 5"/>
+          <p:cNvSpPr txBox="1"/>
+          <p:nvPr/>
+        </p:nvSpPr>
+        <p:spPr>
+          <a:xfrm>
+            <a:off x="548640" y="3685032"/>
+            <a:ext cx="457200" cy="256032"/>
+          </a:xfrm>
+          <a:prstGeom prst="rect">
+            <a:avLst/>
+          </a:prstGeom>
+          <a:noFill/>
+          <a:ln/>
+        </p:spPr>
+        <p:txBody>
+          <a:bodyPr wrap="square" lIns="0" tIns="0" rIns="0" bIns="0" rtlCol="0" anchor="ctr"/>
+          <a:lstStyle/>
+          <a:p>
+            <a:pPr indent="0" marL="0">
+              <a:buNone/>
+            </a:pPr>
+            <a:r>
+              <a:rPr lang="en-US" sz="1200" b="1" dirty="0">
+                <a:solidFill>
+                  <a:srgbClr val="595959"/>
+                </a:solidFill>
+                <a:latin typeface="Arial" pitchFamily="34" charset="0"/>
+                <a:ea typeface="Arial" pitchFamily="34" charset="-122"/>
+                <a:cs typeface="Arial" pitchFamily="34" charset="-120"/>
+              </a:rPr>
+              <a:t>02</a:t>
+            </a:r>
+            <a:endParaRPr lang="en-US" sz="1200" dirty="0"/>
+          </a:p>
+        </p:txBody>
+      </p:sp>
+      <p:sp>
+        <p:nvSpPr>
+          <p:cNvPr id="9" name="Text 6"/>
+          <p:cNvSpPr txBox="1"/>
+          <p:nvPr/>
+        </p:nvSpPr>
+        <p:spPr>
+          <a:xfrm>
+            <a:off x="1005840" y="3685032"/>
+            <a:ext cx="2743200" cy="256032"/>
+          </a:xfrm>
+          <a:prstGeom prst="rect">
+            <a:avLst/>
+          </a:prstGeom>
+          <a:noFill/>
+          <a:ln/>
+        </p:spPr>
+        <p:txBody>
+          <a:bodyPr wrap="square" lIns="0" tIns="0" rIns="0" bIns="0" rtlCol="0" anchor="ctr"/>
+          <a:lstStyle/>
+          <a:p>
+            <a:pPr indent="0" marL="0">
+              <a:buNone/>
+            </a:pPr>
+            <a:r>
+              <a:rPr lang="en-US" sz="1200" dirty="0">
+                <a:solidFill>
+                  <a:srgbClr val="595959"/>
+                </a:solidFill>
+                <a:latin typeface="Arial" pitchFamily="34" charset="0"/>
+                <a:ea typeface="Arial" pitchFamily="34" charset="-122"/>
+                <a:cs typeface="Arial" pitchFamily="34" charset="-120"/>
+              </a:rPr>
+              <a:t>Define</a:t>
+            </a:r>
+            <a:endParaRPr lang="en-US" sz="1200" dirty="0"/>
+          </a:p>
+        </p:txBody>
+      </p:sp>
+      <p:sp>
+        <p:nvSpPr>
+          <p:cNvPr id="10" name="Text 7"/>
+          <p:cNvSpPr txBox="1"/>
+          <p:nvPr/>
+        </p:nvSpPr>
+        <p:spPr>
+          <a:xfrm>
+            <a:off x="548640" y="3941064"/>
+            <a:ext cx="457200" cy="256032"/>
+          </a:xfrm>
+          <a:prstGeom prst="rect">
+            <a:avLst/>
+          </a:prstGeom>
+          <a:noFill/>
+          <a:ln/>
+        </p:spPr>
+        <p:txBody>
+          <a:bodyPr wrap="square" lIns="0" tIns="0" rIns="0" bIns="0" rtlCol="0" anchor="ctr"/>
+          <a:lstStyle/>
+          <a:p>
+            <a:pPr indent="0" marL="0">
+              <a:buNone/>
+            </a:pPr>
+            <a:r>
+              <a:rPr lang="en-US" sz="1200" b="1" dirty="0">
+                <a:solidFill>
+                  <a:srgbClr val="595959"/>
+                </a:solidFill>
+                <a:latin typeface="Arial" pitchFamily="34" charset="0"/>
+                <a:ea typeface="Arial" pitchFamily="34" charset="-122"/>
+                <a:cs typeface="Arial" pitchFamily="34" charset="-120"/>
+              </a:rPr>
+              <a:t>03</a:t>
+            </a:r>
+            <a:endParaRPr lang="en-US" sz="1200" dirty="0"/>
+          </a:p>
+        </p:txBody>
+      </p:sp>
+      <p:sp>
+        <p:nvSpPr>
+          <p:cNvPr id="11" name="Text 8"/>
+          <p:cNvSpPr txBox="1"/>
+          <p:nvPr/>
+        </p:nvSpPr>
+        <p:spPr>
+          <a:xfrm>
+            <a:off x="1005840" y="3941064"/>
+            <a:ext cx="2743200" cy="256032"/>
+          </a:xfrm>
+          <a:prstGeom prst="rect">
+            <a:avLst/>
+          </a:prstGeom>
+          <a:noFill/>
+          <a:ln/>
+        </p:spPr>
+        <p:txBody>
+          <a:bodyPr wrap="square" lIns="0" tIns="0" rIns="0" bIns="0" rtlCol="0" anchor="ctr"/>
+          <a:lstStyle/>
+          <a:p>
+            <a:pPr indent="0" marL="0">
+              <a:buNone/>
+            </a:pPr>
+            <a:r>
+              <a:rPr lang="en-US" sz="1200" dirty="0">
+                <a:solidFill>
+                  <a:srgbClr val="595959"/>
+                </a:solidFill>
+                <a:latin typeface="Arial" pitchFamily="34" charset="0"/>
+                <a:ea typeface="Arial" pitchFamily="34" charset="-122"/>
+                <a:cs typeface="Arial" pitchFamily="34" charset="-120"/>
+              </a:rPr>
+              <a:t>Ideate</a:t>
+            </a:r>
+            <a:endParaRPr lang="en-US" sz="1200" dirty="0"/>
+          </a:p>
+        </p:txBody>
+      </p:sp>
+      <p:sp>
+        <p:nvSpPr>
+          <p:cNvPr id="12" name="Text 9"/>
+          <p:cNvSpPr txBox="1"/>
+          <p:nvPr/>
+        </p:nvSpPr>
+        <p:spPr>
+          <a:xfrm>
+            <a:off x="548640" y="4197096"/>
+            <a:ext cx="457200" cy="256032"/>
+          </a:xfrm>
+          <a:prstGeom prst="rect">
+            <a:avLst/>
+          </a:prstGeom>
+          <a:noFill/>
+          <a:ln/>
+        </p:spPr>
+        <p:txBody>
+          <a:bodyPr wrap="square" lIns="0" tIns="0" rIns="0" bIns="0" rtlCol="0" anchor="ctr"/>
+          <a:lstStyle/>
+          <a:p>
+            <a:pPr indent="0" marL="0">
+              <a:buNone/>
+            </a:pPr>
+            <a:r>
+              <a:rPr lang="en-US" sz="1200" b="1" dirty="0">
+                <a:solidFill>
+                  <a:srgbClr val="595959"/>
+                </a:solidFill>
+                <a:latin typeface="Arial" pitchFamily="34" charset="0"/>
+                <a:ea typeface="Arial" pitchFamily="34" charset="-122"/>
+                <a:cs typeface="Arial" pitchFamily="34" charset="-120"/>
+              </a:rPr>
+              <a:t>04</a:t>
+            </a:r>
+            <a:endParaRPr lang="en-US" sz="1200" dirty="0"/>
+          </a:p>
+        </p:txBody>
+      </p:sp>
+      <p:sp>
+        <p:nvSpPr>
+          <p:cNvPr id="13" name="Text 10"/>
+          <p:cNvSpPr txBox="1"/>
+          <p:nvPr/>
+        </p:nvSpPr>
+        <p:spPr>
+          <a:xfrm>
+            <a:off x="1005840" y="4197096"/>
+            <a:ext cx="2743200" cy="256032"/>
+          </a:xfrm>
+          <a:prstGeom prst="rect">
+            <a:avLst/>
+          </a:prstGeom>
+          <a:noFill/>
+          <a:ln/>
+        </p:spPr>
+        <p:txBody>
+          <a:bodyPr wrap="square" lIns="0" tIns="0" rIns="0" bIns="0" rtlCol="0" anchor="ctr"/>
+          <a:lstStyle/>
+          <a:p>
+            <a:pPr indent="0" marL="0">
+              <a:buNone/>
+            </a:pPr>
+            <a:r>
+              <a:rPr lang="en-US" sz="1200" dirty="0">
+                <a:solidFill>
+                  <a:srgbClr val="595959"/>
+                </a:solidFill>
+                <a:latin typeface="Arial" pitchFamily="34" charset="0"/>
+                <a:ea typeface="Arial" pitchFamily="34" charset="-122"/>
+                <a:cs typeface="Arial" pitchFamily="34" charset="-120"/>
+              </a:rPr>
+              <a:t>Prototype</a:t>
+            </a:r>
+            <a:endParaRPr lang="en-US" sz="1200" dirty="0"/>
+          </a:p>
+        </p:txBody>
+      </p:sp>
+      <p:sp>
+        <p:nvSpPr>
+          <p:cNvPr id="14" name="Text 11"/>
+          <p:cNvSpPr txBox="1"/>
+          <p:nvPr/>
+        </p:nvSpPr>
+        <p:spPr>
+          <a:xfrm>
+            <a:off x="548640" y="4453128"/>
+            <a:ext cx="457200" cy="256032"/>
+          </a:xfrm>
+          <a:prstGeom prst="rect">
+            <a:avLst/>
+          </a:prstGeom>
+          <a:noFill/>
+          <a:ln/>
+        </p:spPr>
+        <p:txBody>
+          <a:bodyPr wrap="square" lIns="0" tIns="0" rIns="0" bIns="0" rtlCol="0" anchor="ctr"/>
+          <a:lstStyle/>
+          <a:p>
+            <a:pPr indent="0" marL="0">
+              <a:buNone/>
+            </a:pPr>
+            <a:r>
+              <a:rPr lang="en-US" sz="1200" b="1" dirty="0">
+                <a:solidFill>
+                  <a:srgbClr val="595959"/>
+                </a:solidFill>
+                <a:latin typeface="Arial" pitchFamily="34" charset="0"/>
+                <a:ea typeface="Arial" pitchFamily="34" charset="-122"/>
+                <a:cs typeface="Arial" pitchFamily="34" charset="-120"/>
+              </a:rPr>
+              <a:t>05</a:t>
+            </a:r>
+            <a:endParaRPr lang="en-US" sz="1200" dirty="0"/>
+          </a:p>
+        </p:txBody>
+      </p:sp>
+      <p:sp>
+        <p:nvSpPr>
+          <p:cNvPr id="15" name="Text 12"/>
+          <p:cNvSpPr txBox="1"/>
+          <p:nvPr/>
+        </p:nvSpPr>
+        <p:spPr>
+          <a:xfrm>
+            <a:off x="1005840" y="4453128"/>
+            <a:ext cx="2743200" cy="256032"/>
+          </a:xfrm>
+          <a:prstGeom prst="rect">
+            <a:avLst/>
+          </a:prstGeom>
+          <a:noFill/>
+          <a:ln/>
+        </p:spPr>
+        <p:txBody>
+          <a:bodyPr wrap="square" lIns="0" tIns="0" rIns="0" bIns="0" rtlCol="0" anchor="ctr"/>
+          <a:lstStyle/>
+          <a:p>
+            <a:pPr indent="0" marL="0">
+              <a:buNone/>
+            </a:pPr>
+            <a:r>
+              <a:rPr lang="en-US" sz="1200" dirty="0">
+                <a:solidFill>
+                  <a:srgbClr val="595959"/>
+                </a:solidFill>
+                <a:latin typeface="Arial" pitchFamily="34" charset="0"/>
+                <a:ea typeface="Arial" pitchFamily="34" charset="-122"/>
+                <a:cs typeface="Arial" pitchFamily="34" charset="-120"/>
+              </a:rPr>
+              <a:t>Test</a:t>
+            </a:r>
+            <a:endParaRPr lang="en-US" sz="1200" dirty="0"/>
+          </a:p>
+        </p:txBody>
+      </p:sp>
+      <p:sp>
+        <p:nvSpPr>
+          <p:cNvPr id="16" name="Shape 13"/>
           <p:cNvSpPr/>
           <p:nvPr/>
         </p:nvSpPr>
@@ -13037,7 +14828,7 @@
       </p:sp>
       <p:sp>
         <p:nvSpPr>
-          <p:cNvPr id="7" name="Text 4"/>
+          <p:cNvPr id="17" name="Text 14"/>
           <p:cNvSpPr txBox="1"/>
           <p:nvPr/>
         </p:nvSpPr>
@@ -13076,14 +14867,14 @@
       </p:sp>
       <p:sp>
         <p:nvSpPr>
-          <p:cNvPr id="8" name="Text 5"/>
-          <p:cNvSpPr txBox="1"/>
-          <p:nvPr/>
-        </p:nvSpPr>
-        <p:spPr>
-          <a:xfrm>
-            <a:off x="4754880" y="960120"/>
-            <a:ext cx="3657600" cy="960120"/>
+          <p:cNvPr id="18" name="Text 15"/>
+          <p:cNvSpPr txBox="1"/>
+          <p:nvPr/>
+        </p:nvSpPr>
+        <p:spPr>
+          <a:xfrm>
+            <a:off x="4754880" y="978408"/>
+            <a:ext cx="3657600" cy="1005840"/>
           </a:xfrm>
           <a:prstGeom prst="rect">
             <a:avLst/>
@@ -13099,7 +14890,7 @@
               <a:buNone/>
             </a:pPr>
             <a:r>
-              <a:rPr lang="en-US" sz="1400" dirty="0">
+              <a:rPr lang="en-US" sz="1500" dirty="0">
                 <a:solidFill>
                   <a:srgbClr val="000000"/>
                 </a:solidFill>
@@ -13109,13 +14900,13 @@
               </a:rPr>
               <a:t>Get to know the people who have the problem. Listen to what they say and watch what they do, before thinking about any solution.</a:t>
             </a:r>
-            <a:endParaRPr lang="en-US" sz="1400" dirty="0"/>
-          </a:p>
-        </p:txBody>
-      </p:sp>
-      <p:sp>
-        <p:nvSpPr>
-          <p:cNvPr id="9" name="Text 6"/>
+            <a:endParaRPr lang="en-US" sz="1500" dirty="0"/>
+          </a:p>
+        </p:txBody>
+      </p:sp>
+      <p:sp>
+        <p:nvSpPr>
+          <p:cNvPr id="19" name="Text 16"/>
           <p:cNvSpPr txBox="1"/>
           <p:nvPr/>
         </p:nvSpPr>
@@ -13154,14 +14945,14 @@
       </p:sp>
       <p:sp>
         <p:nvSpPr>
-          <p:cNvPr id="10" name="Text 7"/>
-          <p:cNvSpPr txBox="1"/>
-          <p:nvPr/>
-        </p:nvSpPr>
-        <p:spPr>
-          <a:xfrm>
-            <a:off x="4754880" y="2331720"/>
-            <a:ext cx="3657600" cy="960120"/>
+          <p:cNvPr id="20" name="Text 17"/>
+          <p:cNvSpPr txBox="1"/>
+          <p:nvPr/>
+        </p:nvSpPr>
+        <p:spPr>
+          <a:xfrm>
+            <a:off x="4754880" y="2350008"/>
+            <a:ext cx="3657600" cy="1005840"/>
           </a:xfrm>
           <a:prstGeom prst="rect">
             <a:avLst/>
@@ -13177,7 +14968,7 @@
               <a:buNone/>
             </a:pPr>
             <a:r>
-              <a:rPr lang="en-US" sz="1400" dirty="0">
+              <a:rPr lang="en-US" sz="1500" dirty="0">
                 <a:solidFill>
                   <a:srgbClr val="000000"/>
                 </a:solidFill>
@@ -13187,13 +14978,13 @@
               </a:rPr>
               <a:t>Who is struggling, and what is frustrating them?</a:t>
             </a:r>
-            <a:endParaRPr lang="en-US" sz="1400" dirty="0"/>
-          </a:p>
-        </p:txBody>
-      </p:sp>
-      <p:sp>
-        <p:nvSpPr>
-          <p:cNvPr id="11" name="Text 8"/>
+            <a:endParaRPr lang="en-US" sz="1500" dirty="0"/>
+          </a:p>
+        </p:txBody>
+      </p:sp>
+      <p:sp>
+        <p:nvSpPr>
+          <p:cNvPr id="21" name="Text 18"/>
           <p:cNvSpPr txBox="1"/>
           <p:nvPr/>
         </p:nvSpPr>
@@ -13232,14 +15023,14 @@
       </p:sp>
       <p:sp>
         <p:nvSpPr>
-          <p:cNvPr id="12" name="Text 9"/>
-          <p:cNvSpPr txBox="1"/>
-          <p:nvPr/>
-        </p:nvSpPr>
-        <p:spPr>
-          <a:xfrm>
-            <a:off x="4754880" y="3703320"/>
-            <a:ext cx="3657600" cy="960120"/>
+          <p:cNvPr id="22" name="Text 19"/>
+          <p:cNvSpPr txBox="1"/>
+          <p:nvPr/>
+        </p:nvSpPr>
+        <p:spPr>
+          <a:xfrm>
+            <a:off x="4754880" y="3721608"/>
+            <a:ext cx="3657600" cy="1005840"/>
           </a:xfrm>
           <a:prstGeom prst="rect">
             <a:avLst/>
@@ -13255,7 +15046,7 @@
               <a:buNone/>
             </a:pPr>
             <a:r>
-              <a:rPr lang="en-US" sz="1400" dirty="0">
+              <a:rPr lang="en-US" sz="1500" dirty="0">
                 <a:solidFill>
                   <a:srgbClr val="000000"/>
                 </a:solidFill>
@@ -13265,7 +15056,7 @@
               </a:rPr>
               <a:t>read real forum threads, GitHub issues and Reddit posts, and ran local AI on a normal 8 GB gaming GPU ourselves.</a:t>
             </a:r>
-            <a:endParaRPr lang="en-US" sz="1400" dirty="0"/>
+            <a:endParaRPr lang="en-US" sz="1500" dirty="0"/>
           </a:p>
         </p:txBody>
       </p:sp>
@@ -14065,8 +15856,8 @@
         </p:nvSpPr>
         <p:spPr>
           <a:xfrm>
-            <a:off x="640080" y="1645920"/>
-            <a:ext cx="2377440" cy="365760"/>
+            <a:off x="640080" y="1828800"/>
+            <a:ext cx="2377440" cy="457200"/>
           </a:xfrm>
           <a:prstGeom prst="rect">
             <a:avLst/>
@@ -14082,7 +15873,7 @@
               <a:buNone/>
             </a:pPr>
             <a:r>
-              <a:rPr lang="en-US" sz="1800" b="1" dirty="0">
+              <a:rPr lang="en-US" sz="2000" b="1" dirty="0">
                 <a:solidFill>
                   <a:srgbClr val="FFFFFF"/>
                 </a:solidFill>
@@ -14092,46 +15883,46 @@
               </a:rPr>
               <a:t>The local AI builder</a:t>
             </a:r>
+            <a:endParaRPr lang="en-US" sz="2000" dirty="0"/>
+          </a:p>
+        </p:txBody>
+      </p:sp>
+      <p:sp>
+        <p:nvSpPr>
+          <p:cNvPr id="9" name="Text 6"/>
+          <p:cNvSpPr txBox="1"/>
+          <p:nvPr/>
+        </p:nvSpPr>
+        <p:spPr>
+          <a:xfrm>
+            <a:off x="685800" y="2514600"/>
+            <a:ext cx="2286000" cy="1280160"/>
+          </a:xfrm>
+          <a:prstGeom prst="rect">
+            <a:avLst/>
+          </a:prstGeom>
+          <a:noFill/>
+          <a:ln/>
+        </p:spPr>
+        <p:txBody>
+          <a:bodyPr wrap="square" lIns="0" tIns="0" rIns="0" bIns="0" rtlCol="0" anchor="t"/>
+          <a:lstStyle/>
+          <a:p>
+            <a:pPr algn="ctr" indent="0" marL="0">
+              <a:buNone/>
+            </a:pPr>
+            <a:r>
+              <a:rPr lang="en-US" sz="1800" i="1" dirty="0">
+                <a:solidFill>
+                  <a:srgbClr val="BFBFBF"/>
+                </a:solidFill>
+                <a:latin typeface="Arial" pitchFamily="34" charset="0"/>
+                <a:ea typeface="Arial" pitchFamily="34" charset="-122"/>
+                <a:cs typeface="Arial" pitchFamily="34" charset="-120"/>
+              </a:rPr>
+              <a:t>“I paid for this GPU. Why is my AI so slow?”</a:t>
+            </a:r>
             <a:endParaRPr lang="en-US" sz="1800" dirty="0"/>
-          </a:p>
-        </p:txBody>
-      </p:sp>
-      <p:sp>
-        <p:nvSpPr>
-          <p:cNvPr id="9" name="Text 6"/>
-          <p:cNvSpPr txBox="1"/>
-          <p:nvPr/>
-        </p:nvSpPr>
-        <p:spPr>
-          <a:xfrm>
-            <a:off x="685800" y="2194560"/>
-            <a:ext cx="2286000" cy="1097280"/>
-          </a:xfrm>
-          <a:prstGeom prst="rect">
-            <a:avLst/>
-          </a:prstGeom>
-          <a:noFill/>
-          <a:ln/>
-        </p:spPr>
-        <p:txBody>
-          <a:bodyPr wrap="square" lIns="0" tIns="0" rIns="0" bIns="0" rtlCol="0" anchor="t"/>
-          <a:lstStyle/>
-          <a:p>
-            <a:pPr algn="ctr" indent="0" marL="0">
-              <a:buNone/>
-            </a:pPr>
-            <a:r>
-              <a:rPr lang="en-US" sz="1600" i="1" dirty="0">
-                <a:solidFill>
-                  <a:srgbClr val="BFBFBF"/>
-                </a:solidFill>
-                <a:latin typeface="Arial" pitchFamily="34" charset="0"/>
-                <a:ea typeface="Arial" pitchFamily="34" charset="-122"/>
-                <a:cs typeface="Arial" pitchFamily="34" charset="-120"/>
-              </a:rPr>
-              <a:t>“I paid for this GPU. Why is my AI so slow?”</a:t>
-            </a:r>
-            <a:endParaRPr lang="en-US" sz="1600" dirty="0"/>
           </a:p>
         </p:txBody>
       </p:sp>
@@ -14565,8 +16356,8 @@
         </p:nvSpPr>
         <p:spPr>
           <a:xfrm>
-            <a:off x="548640" y="2697480"/>
-            <a:ext cx="3474720" cy="914400"/>
+            <a:off x="548640" y="2560320"/>
+            <a:ext cx="3474720" cy="640080"/>
           </a:xfrm>
           <a:prstGeom prst="rect">
             <a:avLst/>
@@ -14582,7 +16373,7 @@
               <a:buNone/>
             </a:pPr>
             <a:r>
-              <a:rPr lang="en-US" sz="1800" i="1" dirty="0">
+              <a:rPr lang="en-US" sz="1600" i="1" dirty="0">
                 <a:solidFill>
                   <a:srgbClr val="BFBFBF"/>
                 </a:solidFill>
@@ -14592,13 +16383,403 @@
               </a:rPr>
               <a:t>A clear problem is half the solution.</a:t>
             </a:r>
-            <a:endParaRPr lang="en-US" sz="1800" dirty="0"/>
-          </a:p>
-        </p:txBody>
-      </p:sp>
-      <p:sp>
-        <p:nvSpPr>
-          <p:cNvPr id="6" name="Shape 3"/>
+            <a:endParaRPr lang="en-US" sz="1600" dirty="0"/>
+          </a:p>
+        </p:txBody>
+      </p:sp>
+      <p:sp>
+        <p:nvSpPr>
+          <p:cNvPr id="6" name="Text 3"/>
+          <p:cNvSpPr txBox="1"/>
+          <p:nvPr/>
+        </p:nvSpPr>
+        <p:spPr>
+          <a:xfrm>
+            <a:off x="548640" y="3429000"/>
+            <a:ext cx="457200" cy="256032"/>
+          </a:xfrm>
+          <a:prstGeom prst="rect">
+            <a:avLst/>
+          </a:prstGeom>
+          <a:noFill/>
+          <a:ln/>
+        </p:spPr>
+        <p:txBody>
+          <a:bodyPr wrap="square" lIns="0" tIns="0" rIns="0" bIns="0" rtlCol="0" anchor="ctr"/>
+          <a:lstStyle/>
+          <a:p>
+            <a:pPr indent="0" marL="0">
+              <a:buNone/>
+            </a:pPr>
+            <a:r>
+              <a:rPr lang="en-US" sz="1200" b="1" dirty="0">
+                <a:solidFill>
+                  <a:srgbClr val="595959"/>
+                </a:solidFill>
+                <a:latin typeface="Arial" pitchFamily="34" charset="0"/>
+                <a:ea typeface="Arial" pitchFamily="34" charset="-122"/>
+                <a:cs typeface="Arial" pitchFamily="34" charset="-120"/>
+              </a:rPr>
+              <a:t>01</a:t>
+            </a:r>
+            <a:endParaRPr lang="en-US" sz="1200" dirty="0"/>
+          </a:p>
+        </p:txBody>
+      </p:sp>
+      <p:sp>
+        <p:nvSpPr>
+          <p:cNvPr id="7" name="Text 4"/>
+          <p:cNvSpPr txBox="1"/>
+          <p:nvPr/>
+        </p:nvSpPr>
+        <p:spPr>
+          <a:xfrm>
+            <a:off x="1005840" y="3429000"/>
+            <a:ext cx="2743200" cy="256032"/>
+          </a:xfrm>
+          <a:prstGeom prst="rect">
+            <a:avLst/>
+          </a:prstGeom>
+          <a:noFill/>
+          <a:ln/>
+        </p:spPr>
+        <p:txBody>
+          <a:bodyPr wrap="square" lIns="0" tIns="0" rIns="0" bIns="0" rtlCol="0" anchor="ctr"/>
+          <a:lstStyle/>
+          <a:p>
+            <a:pPr indent="0" marL="0">
+              <a:buNone/>
+            </a:pPr>
+            <a:r>
+              <a:rPr lang="en-US" sz="1200" dirty="0">
+                <a:solidFill>
+                  <a:srgbClr val="595959"/>
+                </a:solidFill>
+                <a:latin typeface="Arial" pitchFamily="34" charset="0"/>
+                <a:ea typeface="Arial" pitchFamily="34" charset="-122"/>
+                <a:cs typeface="Arial" pitchFamily="34" charset="-120"/>
+              </a:rPr>
+              <a:t>Empathize</a:t>
+            </a:r>
+            <a:endParaRPr lang="en-US" sz="1200" dirty="0"/>
+          </a:p>
+        </p:txBody>
+      </p:sp>
+      <p:sp>
+        <p:nvSpPr>
+          <p:cNvPr id="8" name="Text 5"/>
+          <p:cNvSpPr txBox="1"/>
+          <p:nvPr/>
+        </p:nvSpPr>
+        <p:spPr>
+          <a:xfrm>
+            <a:off x="548640" y="3685032"/>
+            <a:ext cx="457200" cy="256032"/>
+          </a:xfrm>
+          <a:prstGeom prst="rect">
+            <a:avLst/>
+          </a:prstGeom>
+          <a:noFill/>
+          <a:ln/>
+        </p:spPr>
+        <p:txBody>
+          <a:bodyPr wrap="square" lIns="0" tIns="0" rIns="0" bIns="0" rtlCol="0" anchor="ctr"/>
+          <a:lstStyle/>
+          <a:p>
+            <a:pPr indent="0" marL="0">
+              <a:buNone/>
+            </a:pPr>
+            <a:r>
+              <a:rPr lang="en-US" sz="1200" b="1" dirty="0">
+                <a:solidFill>
+                  <a:srgbClr val="FFFFFF"/>
+                </a:solidFill>
+                <a:latin typeface="Arial" pitchFamily="34" charset="0"/>
+                <a:ea typeface="Arial" pitchFamily="34" charset="-122"/>
+                <a:cs typeface="Arial" pitchFamily="34" charset="-120"/>
+              </a:rPr>
+              <a:t>02</a:t>
+            </a:r>
+            <a:endParaRPr lang="en-US" sz="1200" dirty="0"/>
+          </a:p>
+        </p:txBody>
+      </p:sp>
+      <p:sp>
+        <p:nvSpPr>
+          <p:cNvPr id="9" name="Text 6"/>
+          <p:cNvSpPr txBox="1"/>
+          <p:nvPr/>
+        </p:nvSpPr>
+        <p:spPr>
+          <a:xfrm>
+            <a:off x="1005840" y="3685032"/>
+            <a:ext cx="2743200" cy="256032"/>
+          </a:xfrm>
+          <a:prstGeom prst="rect">
+            <a:avLst/>
+          </a:prstGeom>
+          <a:noFill/>
+          <a:ln/>
+        </p:spPr>
+        <p:txBody>
+          <a:bodyPr wrap="square" lIns="0" tIns="0" rIns="0" bIns="0" rtlCol="0" anchor="ctr"/>
+          <a:lstStyle/>
+          <a:p>
+            <a:pPr indent="0" marL="0">
+              <a:buNone/>
+            </a:pPr>
+            <a:r>
+              <a:rPr lang="en-US" sz="1200" b="1" dirty="0">
+                <a:solidFill>
+                  <a:srgbClr val="FFFFFF"/>
+                </a:solidFill>
+                <a:latin typeface="Arial" pitchFamily="34" charset="0"/>
+                <a:ea typeface="Arial" pitchFamily="34" charset="-122"/>
+                <a:cs typeface="Arial" pitchFamily="34" charset="-120"/>
+              </a:rPr>
+              <a:t>Define</a:t>
+            </a:r>
+            <a:endParaRPr lang="en-US" sz="1200" dirty="0"/>
+          </a:p>
+        </p:txBody>
+      </p:sp>
+      <p:sp>
+        <p:nvSpPr>
+          <p:cNvPr id="10" name="Text 7"/>
+          <p:cNvSpPr txBox="1"/>
+          <p:nvPr/>
+        </p:nvSpPr>
+        <p:spPr>
+          <a:xfrm>
+            <a:off x="548640" y="3941064"/>
+            <a:ext cx="457200" cy="256032"/>
+          </a:xfrm>
+          <a:prstGeom prst="rect">
+            <a:avLst/>
+          </a:prstGeom>
+          <a:noFill/>
+          <a:ln/>
+        </p:spPr>
+        <p:txBody>
+          <a:bodyPr wrap="square" lIns="0" tIns="0" rIns="0" bIns="0" rtlCol="0" anchor="ctr"/>
+          <a:lstStyle/>
+          <a:p>
+            <a:pPr indent="0" marL="0">
+              <a:buNone/>
+            </a:pPr>
+            <a:r>
+              <a:rPr lang="en-US" sz="1200" b="1" dirty="0">
+                <a:solidFill>
+                  <a:srgbClr val="595959"/>
+                </a:solidFill>
+                <a:latin typeface="Arial" pitchFamily="34" charset="0"/>
+                <a:ea typeface="Arial" pitchFamily="34" charset="-122"/>
+                <a:cs typeface="Arial" pitchFamily="34" charset="-120"/>
+              </a:rPr>
+              <a:t>03</a:t>
+            </a:r>
+            <a:endParaRPr lang="en-US" sz="1200" dirty="0"/>
+          </a:p>
+        </p:txBody>
+      </p:sp>
+      <p:sp>
+        <p:nvSpPr>
+          <p:cNvPr id="11" name="Text 8"/>
+          <p:cNvSpPr txBox="1"/>
+          <p:nvPr/>
+        </p:nvSpPr>
+        <p:spPr>
+          <a:xfrm>
+            <a:off x="1005840" y="3941064"/>
+            <a:ext cx="2743200" cy="256032"/>
+          </a:xfrm>
+          <a:prstGeom prst="rect">
+            <a:avLst/>
+          </a:prstGeom>
+          <a:noFill/>
+          <a:ln/>
+        </p:spPr>
+        <p:txBody>
+          <a:bodyPr wrap="square" lIns="0" tIns="0" rIns="0" bIns="0" rtlCol="0" anchor="ctr"/>
+          <a:lstStyle/>
+          <a:p>
+            <a:pPr indent="0" marL="0">
+              <a:buNone/>
+            </a:pPr>
+            <a:r>
+              <a:rPr lang="en-US" sz="1200" dirty="0">
+                <a:solidFill>
+                  <a:srgbClr val="595959"/>
+                </a:solidFill>
+                <a:latin typeface="Arial" pitchFamily="34" charset="0"/>
+                <a:ea typeface="Arial" pitchFamily="34" charset="-122"/>
+                <a:cs typeface="Arial" pitchFamily="34" charset="-120"/>
+              </a:rPr>
+              <a:t>Ideate</a:t>
+            </a:r>
+            <a:endParaRPr lang="en-US" sz="1200" dirty="0"/>
+          </a:p>
+        </p:txBody>
+      </p:sp>
+      <p:sp>
+        <p:nvSpPr>
+          <p:cNvPr id="12" name="Text 9"/>
+          <p:cNvSpPr txBox="1"/>
+          <p:nvPr/>
+        </p:nvSpPr>
+        <p:spPr>
+          <a:xfrm>
+            <a:off x="548640" y="4197096"/>
+            <a:ext cx="457200" cy="256032"/>
+          </a:xfrm>
+          <a:prstGeom prst="rect">
+            <a:avLst/>
+          </a:prstGeom>
+          <a:noFill/>
+          <a:ln/>
+        </p:spPr>
+        <p:txBody>
+          <a:bodyPr wrap="square" lIns="0" tIns="0" rIns="0" bIns="0" rtlCol="0" anchor="ctr"/>
+          <a:lstStyle/>
+          <a:p>
+            <a:pPr indent="0" marL="0">
+              <a:buNone/>
+            </a:pPr>
+            <a:r>
+              <a:rPr lang="en-US" sz="1200" b="1" dirty="0">
+                <a:solidFill>
+                  <a:srgbClr val="595959"/>
+                </a:solidFill>
+                <a:latin typeface="Arial" pitchFamily="34" charset="0"/>
+                <a:ea typeface="Arial" pitchFamily="34" charset="-122"/>
+                <a:cs typeface="Arial" pitchFamily="34" charset="-120"/>
+              </a:rPr>
+              <a:t>04</a:t>
+            </a:r>
+            <a:endParaRPr lang="en-US" sz="1200" dirty="0"/>
+          </a:p>
+        </p:txBody>
+      </p:sp>
+      <p:sp>
+        <p:nvSpPr>
+          <p:cNvPr id="13" name="Text 10"/>
+          <p:cNvSpPr txBox="1"/>
+          <p:nvPr/>
+        </p:nvSpPr>
+        <p:spPr>
+          <a:xfrm>
+            <a:off x="1005840" y="4197096"/>
+            <a:ext cx="2743200" cy="256032"/>
+          </a:xfrm>
+          <a:prstGeom prst="rect">
+            <a:avLst/>
+          </a:prstGeom>
+          <a:noFill/>
+          <a:ln/>
+        </p:spPr>
+        <p:txBody>
+          <a:bodyPr wrap="square" lIns="0" tIns="0" rIns="0" bIns="0" rtlCol="0" anchor="ctr"/>
+          <a:lstStyle/>
+          <a:p>
+            <a:pPr indent="0" marL="0">
+              <a:buNone/>
+            </a:pPr>
+            <a:r>
+              <a:rPr lang="en-US" sz="1200" dirty="0">
+                <a:solidFill>
+                  <a:srgbClr val="595959"/>
+                </a:solidFill>
+                <a:latin typeface="Arial" pitchFamily="34" charset="0"/>
+                <a:ea typeface="Arial" pitchFamily="34" charset="-122"/>
+                <a:cs typeface="Arial" pitchFamily="34" charset="-120"/>
+              </a:rPr>
+              <a:t>Prototype</a:t>
+            </a:r>
+            <a:endParaRPr lang="en-US" sz="1200" dirty="0"/>
+          </a:p>
+        </p:txBody>
+      </p:sp>
+      <p:sp>
+        <p:nvSpPr>
+          <p:cNvPr id="14" name="Text 11"/>
+          <p:cNvSpPr txBox="1"/>
+          <p:nvPr/>
+        </p:nvSpPr>
+        <p:spPr>
+          <a:xfrm>
+            <a:off x="548640" y="4453128"/>
+            <a:ext cx="457200" cy="256032"/>
+          </a:xfrm>
+          <a:prstGeom prst="rect">
+            <a:avLst/>
+          </a:prstGeom>
+          <a:noFill/>
+          <a:ln/>
+        </p:spPr>
+        <p:txBody>
+          <a:bodyPr wrap="square" lIns="0" tIns="0" rIns="0" bIns="0" rtlCol="0" anchor="ctr"/>
+          <a:lstStyle/>
+          <a:p>
+            <a:pPr indent="0" marL="0">
+              <a:buNone/>
+            </a:pPr>
+            <a:r>
+              <a:rPr lang="en-US" sz="1200" b="1" dirty="0">
+                <a:solidFill>
+                  <a:srgbClr val="595959"/>
+                </a:solidFill>
+                <a:latin typeface="Arial" pitchFamily="34" charset="0"/>
+                <a:ea typeface="Arial" pitchFamily="34" charset="-122"/>
+                <a:cs typeface="Arial" pitchFamily="34" charset="-120"/>
+              </a:rPr>
+              <a:t>05</a:t>
+            </a:r>
+            <a:endParaRPr lang="en-US" sz="1200" dirty="0"/>
+          </a:p>
+        </p:txBody>
+      </p:sp>
+      <p:sp>
+        <p:nvSpPr>
+          <p:cNvPr id="15" name="Text 12"/>
+          <p:cNvSpPr txBox="1"/>
+          <p:nvPr/>
+        </p:nvSpPr>
+        <p:spPr>
+          <a:xfrm>
+            <a:off x="1005840" y="4453128"/>
+            <a:ext cx="2743200" cy="256032"/>
+          </a:xfrm>
+          <a:prstGeom prst="rect">
+            <a:avLst/>
+          </a:prstGeom>
+          <a:noFill/>
+          <a:ln/>
+        </p:spPr>
+        <p:txBody>
+          <a:bodyPr wrap="square" lIns="0" tIns="0" rIns="0" bIns="0" rtlCol="0" anchor="ctr"/>
+          <a:lstStyle/>
+          <a:p>
+            <a:pPr indent="0" marL="0">
+              <a:buNone/>
+            </a:pPr>
+            <a:r>
+              <a:rPr lang="en-US" sz="1200" dirty="0">
+                <a:solidFill>
+                  <a:srgbClr val="595959"/>
+                </a:solidFill>
+                <a:latin typeface="Arial" pitchFamily="34" charset="0"/>
+                <a:ea typeface="Arial" pitchFamily="34" charset="-122"/>
+                <a:cs typeface="Arial" pitchFamily="34" charset="-120"/>
+              </a:rPr>
+              <a:t>Test</a:t>
+            </a:r>
+            <a:endParaRPr lang="en-US" sz="1200" dirty="0"/>
+          </a:p>
+        </p:txBody>
+      </p:sp>
+      <p:sp>
+        <p:nvSpPr>
+          <p:cNvPr id="16" name="Shape 13"/>
           <p:cNvSpPr/>
           <p:nvPr/>
         </p:nvSpPr>
@@ -14623,7 +16804,7 @@
       </p:sp>
       <p:sp>
         <p:nvSpPr>
-          <p:cNvPr id="7" name="Text 4"/>
+          <p:cNvPr id="17" name="Text 14"/>
           <p:cNvSpPr txBox="1"/>
           <p:nvPr/>
         </p:nvSpPr>
@@ -14662,14 +16843,14 @@
       </p:sp>
       <p:sp>
         <p:nvSpPr>
-          <p:cNvPr id="8" name="Text 5"/>
-          <p:cNvSpPr txBox="1"/>
-          <p:nvPr/>
-        </p:nvSpPr>
-        <p:spPr>
-          <a:xfrm>
-            <a:off x="4754880" y="960120"/>
-            <a:ext cx="3657600" cy="960120"/>
+          <p:cNvPr id="18" name="Text 15"/>
+          <p:cNvSpPr txBox="1"/>
+          <p:nvPr/>
+        </p:nvSpPr>
+        <p:spPr>
+          <a:xfrm>
+            <a:off x="4754880" y="978408"/>
+            <a:ext cx="3657600" cy="1005840"/>
           </a:xfrm>
           <a:prstGeom prst="rect">
             <a:avLst/>
@@ -14685,7 +16866,7 @@
               <a:buNone/>
             </a:pPr>
             <a:r>
-              <a:rPr lang="en-US" sz="1400" dirty="0">
+              <a:rPr lang="en-US" sz="1500" dirty="0">
                 <a:solidFill>
                   <a:srgbClr val="000000"/>
                 </a:solidFill>
@@ -14695,13 +16876,13 @@
               </a:rPr>
               <a:t>Turn everything you learned into one short, clear problem statement that the whole team agrees on.</a:t>
             </a:r>
-            <a:endParaRPr lang="en-US" sz="1400" dirty="0"/>
-          </a:p>
-        </p:txBody>
-      </p:sp>
-      <p:sp>
-        <p:nvSpPr>
-          <p:cNvPr id="9" name="Text 6"/>
+            <a:endParaRPr lang="en-US" sz="1500" dirty="0"/>
+          </a:p>
+        </p:txBody>
+      </p:sp>
+      <p:sp>
+        <p:nvSpPr>
+          <p:cNvPr id="19" name="Text 16"/>
           <p:cNvSpPr txBox="1"/>
           <p:nvPr/>
         </p:nvSpPr>
@@ -14740,14 +16921,14 @@
       </p:sp>
       <p:sp>
         <p:nvSpPr>
-          <p:cNvPr id="10" name="Text 7"/>
-          <p:cNvSpPr txBox="1"/>
-          <p:nvPr/>
-        </p:nvSpPr>
-        <p:spPr>
-          <a:xfrm>
-            <a:off x="4754880" y="2331720"/>
-            <a:ext cx="3657600" cy="960120"/>
+          <p:cNvPr id="20" name="Text 17"/>
+          <p:cNvSpPr txBox="1"/>
+          <p:nvPr/>
+        </p:nvSpPr>
+        <p:spPr>
+          <a:xfrm>
+            <a:off x="4754880" y="2350008"/>
+            <a:ext cx="3657600" cy="1005840"/>
           </a:xfrm>
           <a:prstGeom prst="rect">
             <a:avLst/>
@@ -14763,7 +16944,7 @@
               <a:buNone/>
             </a:pPr>
             <a:r>
-              <a:rPr lang="en-US" sz="1400" dirty="0">
+              <a:rPr lang="en-US" sz="1500" dirty="0">
                 <a:solidFill>
                   <a:srgbClr val="000000"/>
                 </a:solidFill>
@@ -14773,13 +16954,13 @@
               </a:rPr>
               <a:t>What is the real problem we are trying to solve?</a:t>
             </a:r>
-            <a:endParaRPr lang="en-US" sz="1400" dirty="0"/>
-          </a:p>
-        </p:txBody>
-      </p:sp>
-      <p:sp>
-        <p:nvSpPr>
-          <p:cNvPr id="11" name="Text 8"/>
+            <a:endParaRPr lang="en-US" sz="1500" dirty="0"/>
+          </a:p>
+        </p:txBody>
+      </p:sp>
+      <p:sp>
+        <p:nvSpPr>
+          <p:cNvPr id="21" name="Text 18"/>
           <p:cNvSpPr txBox="1"/>
           <p:nvPr/>
         </p:nvSpPr>
@@ -14818,14 +16999,14 @@
       </p:sp>
       <p:sp>
         <p:nvSpPr>
-          <p:cNvPr id="12" name="Text 9"/>
-          <p:cNvSpPr txBox="1"/>
-          <p:nvPr/>
-        </p:nvSpPr>
-        <p:spPr>
-          <a:xfrm>
-            <a:off x="4754880" y="3703320"/>
-            <a:ext cx="3657600" cy="960120"/>
+          <p:cNvPr id="22" name="Text 19"/>
+          <p:cNvSpPr txBox="1"/>
+          <p:nvPr/>
+        </p:nvSpPr>
+        <p:spPr>
+          <a:xfrm>
+            <a:off x="4754880" y="3721608"/>
+            <a:ext cx="3657600" cy="1005840"/>
           </a:xfrm>
           <a:prstGeom prst="rect">
             <a:avLst/>
@@ -14841,7 +17022,7 @@
               <a:buNone/>
             </a:pPr>
             <a:r>
-              <a:rPr lang="en-US" sz="1400" dirty="0">
+              <a:rPr lang="en-US" sz="1500" dirty="0">
                 <a:solidFill>
                   <a:srgbClr val="000000"/>
                 </a:solidFill>
@@ -14851,7 +17032,7 @@
               </a:rPr>
               <a:t>boiled the research down to a single “How might we” question and two measurable pains.</a:t>
             </a:r>
-            <a:endParaRPr lang="en-US" sz="1400" dirty="0"/>
+            <a:endParaRPr lang="en-US" sz="1500" dirty="0"/>
           </a:p>
         </p:txBody>
       </p:sp>

</xml_diff>